<commit_message>
Add result source and measurement slides
Expand the Thai presentation with slides explaining where results came from, how model performance was measured, and how API/load performance was evaluated.
</commit_message>
<xml_diff>
--- a/presentation/mobilevit_mlops_presentation.pptx
+++ b/presentation/mobilevit_mlops_presentation.pptx
@@ -19,6 +19,9 @@
     <p:sldId id="267" r:id="rId18"/>
     <p:sldId id="268" r:id="rId19"/>
     <p:sldId id="269" r:id="rId20"/>
+    <p:sldId id="270" r:id="rId21"/>
+    <p:sldId id="271" r:id="rId22"/>
+    <p:sldId id="272" r:id="rId23"/>
   </p:sldIdLst>
   <p:sldSz cx="12191695" cy="6858000" type="screen4x3"/>
   <p:notesSz cx="6858000" cy="9144000"/>
@@ -3353,6 +3356,1044 @@
 </file>
 
 <file path=ppt/slides/slide10.xml><?xml version="1.0" encoding="utf-8"?>
+<p:sld xmlns:a="http://schemas.openxmlformats.org/drawingml/2006/main" xmlns:p="http://schemas.openxmlformats.org/presentationml/2006/main" xmlns:r="http://schemas.openxmlformats.org/officeDocument/2006/relationships">
+  <p:cSld>
+    <p:spTree>
+      <p:nvGrpSpPr>
+        <p:cNvPr id="1" name=""/>
+        <p:cNvGrpSpPr/>
+        <p:nvPr/>
+      </p:nvGrpSpPr>
+      <p:grpSpPr/>
+      <p:sp>
+        <p:nvSpPr>
+          <p:cNvPr id="2" name="TextBox 1"/>
+          <p:cNvSpPr txBox="1"/>
+          <p:nvPr/>
+        </p:nvSpPr>
+        <p:spPr>
+          <a:xfrm>
+            <a:off x="594360" y="320040"/>
+            <a:ext cx="10972800" cy="640080"/>
+          </a:xfrm>
+          <a:prstGeom prst="rect">
+            <a:avLst/>
+          </a:prstGeom>
+          <a:noFill/>
+        </p:spPr>
+        <p:txBody>
+          <a:bodyPr wrap="none">
+            <a:spAutoFit/>
+          </a:bodyPr>
+          <a:lstStyle/>
+          <a:p>
+            <a:pPr algn="l"/>
+            <a:r>
+              <a:rPr sz="2800" b="1">
+                <a:solidFill>
+                  <a:srgbClr val="16365C"/>
+                </a:solidFill>
+                <a:latin typeface="Tahoma"/>
+              </a:rPr>
+              <a:t>วิธีวัดประสิทธิภาพของ API</a:t>
+            </a:r>
+          </a:p>
+        </p:txBody>
+      </p:sp>
+      <p:sp>
+        <p:nvSpPr>
+          <p:cNvPr id="3" name="Rectangle 2"/>
+          <p:cNvSpPr/>
+          <p:nvPr/>
+        </p:nvSpPr>
+        <p:spPr>
+          <a:xfrm>
+            <a:off x="594360" y="1024128"/>
+            <a:ext cx="10972800" cy="36576"/>
+          </a:xfrm>
+          <a:prstGeom prst="rect">
+            <a:avLst/>
+          </a:prstGeom>
+          <a:solidFill>
+            <a:srgbClr val="3275B5"/>
+          </a:solidFill>
+          <a:ln>
+            <a:noFill/>
+          </a:ln>
+        </p:spPr>
+        <p:style>
+          <a:lnRef idx="1">
+            <a:schemeClr val="accent1"/>
+          </a:lnRef>
+          <a:fillRef idx="3">
+            <a:schemeClr val="accent1"/>
+          </a:fillRef>
+          <a:effectRef idx="2">
+            <a:schemeClr val="accent1"/>
+          </a:effectRef>
+          <a:fontRef idx="minor">
+            <a:schemeClr val="lt1"/>
+          </a:fontRef>
+        </p:style>
+        <p:txBody>
+          <a:bodyPr rtlCol="0" anchor="ctr"/>
+          <a:lstStyle/>
+          <a:p>
+            <a:pPr algn="ctr"/>
+          </a:p>
+        </p:txBody>
+      </p:sp>
+      <p:sp>
+        <p:nvSpPr>
+          <p:cNvPr id="4" name="TextBox 3"/>
+          <p:cNvSpPr txBox="1"/>
+          <p:nvPr/>
+        </p:nvSpPr>
+        <p:spPr>
+          <a:xfrm>
+            <a:off x="777240" y="1417320"/>
+            <a:ext cx="10789920" cy="4297680"/>
+          </a:xfrm>
+          <a:prstGeom prst="rect">
+            <a:avLst/>
+          </a:prstGeom>
+          <a:noFill/>
+        </p:spPr>
+        <p:txBody>
+          <a:bodyPr wrap="none">
+            <a:spAutoFit/>
+          </a:bodyPr>
+          <a:lstStyle/>
+          <a:p>
+            <a:pPr>
+              <a:spcAft>
+                <a:spcPts val="800"/>
+              </a:spcAft>
+              <a:defRPr sz="1800">
+                <a:solidFill>
+                  <a:srgbClr val="282828"/>
+                </a:solidFill>
+                <a:latin typeface="Tahoma"/>
+              </a:defRPr>
+            </a:pPr>
+            <a:r>
+              <a:t>ทดสอบ API ด้วย Docker เพื่อให้ใกล้เคียงสภาพแวดล้อม deploy จริง</a:t>
+            </a:r>
+          </a:p>
+          <a:p>
+            <a:pPr>
+              <a:spcAft>
+                <a:spcPts val="800"/>
+              </a:spcAft>
+              <a:defRPr sz="1800">
+                <a:solidFill>
+                  <a:srgbClr val="282828"/>
+                </a:solidFill>
+                <a:latin typeface="Tahoma"/>
+              </a:defRPr>
+            </a:pPr>
+            <a:r>
+              <a:t>ส่งไฟล์รูปภาพจริงเข้า endpoint /predict และตรวจว่า response เป็น JSON ที่ถูกต้อง</a:t>
+            </a:r>
+          </a:p>
+          <a:p>
+            <a:pPr>
+              <a:spcAft>
+                <a:spcPts val="800"/>
+              </a:spcAft>
+              <a:defRPr sz="1800">
+                <a:solidFill>
+                  <a:srgbClr val="282828"/>
+                </a:solidFill>
+                <a:latin typeface="Tahoma"/>
+              </a:defRPr>
+            </a:pPr>
+            <a:r>
+              <a:t>ทดสอบ error handling ด้วยไฟล์ที่ไม่ใช่รูปภาพ เพื่อดูว่า API ตอบ 400 Bad Request</a:t>
+            </a:r>
+          </a:p>
+          <a:p>
+            <a:pPr>
+              <a:spcAft>
+                <a:spcPts val="800"/>
+              </a:spcAft>
+              <a:defRPr sz="1800">
+                <a:solidFill>
+                  <a:srgbClr val="282828"/>
+                </a:solidFill>
+                <a:latin typeface="Tahoma"/>
+              </a:defRPr>
+            </a:pPr>
+            <a:r>
+              <a:t>ทดสอบโหลดด้วย concurrent requests เพื่อดู throughput, average latency และ P95 latency</a:t>
+            </a:r>
+          </a:p>
+          <a:p>
+            <a:pPr>
+              <a:spcAft>
+                <a:spcPts val="800"/>
+              </a:spcAft>
+              <a:defRPr sz="1800">
+                <a:solidFill>
+                  <a:srgbClr val="282828"/>
+                </a:solidFill>
+                <a:latin typeface="Tahoma"/>
+              </a:defRPr>
+            </a:pPr>
+            <a:r>
+              <a:t>ใช้ Error % เป็นตัวบอกว่าระบบเริ่มรับโหลดไม่ไหวหรือไม่</a:t>
+            </a:r>
+          </a:p>
+        </p:txBody>
+      </p:sp>
+      <p:sp>
+        <p:nvSpPr>
+          <p:cNvPr id="5" name="TextBox 4"/>
+          <p:cNvSpPr txBox="1"/>
+          <p:nvPr/>
+        </p:nvSpPr>
+        <p:spPr>
+          <a:xfrm>
+            <a:off x="9646920" y="6446520"/>
+            <a:ext cx="1920240" cy="228600"/>
+          </a:xfrm>
+          <a:prstGeom prst="rect">
+            <a:avLst/>
+          </a:prstGeom>
+          <a:noFill/>
+        </p:spPr>
+        <p:txBody>
+          <a:bodyPr wrap="none">
+            <a:spAutoFit/>
+          </a:bodyPr>
+          <a:lstStyle/>
+          <a:p>
+            <a:pPr algn="r"/>
+            <a:r>
+              <a:rPr sz="900" b="0">
+                <a:solidFill>
+                  <a:srgbClr val="595959"/>
+                </a:solidFill>
+                <a:latin typeface="Tahoma"/>
+              </a:rPr>
+              <a:t>MobileViT MLOps | 10</a:t>
+            </a:r>
+          </a:p>
+        </p:txBody>
+      </p:sp>
+    </p:spTree>
+  </p:cSld>
+  <p:clrMapOvr>
+    <a:masterClrMapping/>
+  </p:clrMapOvr>
+</p:sld>
+</file>
+
+<file path=ppt/slides/slide11.xml><?xml version="1.0" encoding="utf-8"?>
+<p:sld xmlns:a="http://schemas.openxmlformats.org/drawingml/2006/main" xmlns:p="http://schemas.openxmlformats.org/presentationml/2006/main" xmlns:r="http://schemas.openxmlformats.org/officeDocument/2006/relationships">
+  <p:cSld>
+    <p:spTree>
+      <p:nvGrpSpPr>
+        <p:cNvPr id="1" name=""/>
+        <p:cNvGrpSpPr/>
+        <p:nvPr/>
+      </p:nvGrpSpPr>
+      <p:grpSpPr/>
+      <p:sp>
+        <p:nvSpPr>
+          <p:cNvPr id="2" name="TextBox 1"/>
+          <p:cNvSpPr txBox="1"/>
+          <p:nvPr/>
+        </p:nvSpPr>
+        <p:spPr>
+          <a:xfrm>
+            <a:off x="594360" y="320040"/>
+            <a:ext cx="10972800" cy="640080"/>
+          </a:xfrm>
+          <a:prstGeom prst="rect">
+            <a:avLst/>
+          </a:prstGeom>
+          <a:noFill/>
+        </p:spPr>
+        <p:txBody>
+          <a:bodyPr wrap="none">
+            <a:spAutoFit/>
+          </a:bodyPr>
+          <a:lstStyle/>
+          <a:p>
+            <a:pPr algn="l"/>
+            <a:r>
+              <a:rPr sz="2800" b="1">
+                <a:solidFill>
+                  <a:srgbClr val="16365C"/>
+                </a:solidFill>
+                <a:latin typeface="Tahoma"/>
+              </a:rPr>
+              <a:t>API และ Error Handling</a:t>
+            </a:r>
+          </a:p>
+        </p:txBody>
+      </p:sp>
+      <p:sp>
+        <p:nvSpPr>
+          <p:cNvPr id="3" name="Rectangle 2"/>
+          <p:cNvSpPr/>
+          <p:nvPr/>
+        </p:nvSpPr>
+        <p:spPr>
+          <a:xfrm>
+            <a:off x="594360" y="1024128"/>
+            <a:ext cx="10972800" cy="36576"/>
+          </a:xfrm>
+          <a:prstGeom prst="rect">
+            <a:avLst/>
+          </a:prstGeom>
+          <a:solidFill>
+            <a:srgbClr val="3275B5"/>
+          </a:solidFill>
+          <a:ln>
+            <a:noFill/>
+          </a:ln>
+        </p:spPr>
+        <p:style>
+          <a:lnRef idx="1">
+            <a:schemeClr val="accent1"/>
+          </a:lnRef>
+          <a:fillRef idx="3">
+            <a:schemeClr val="accent1"/>
+          </a:fillRef>
+          <a:effectRef idx="2">
+            <a:schemeClr val="accent1"/>
+          </a:effectRef>
+          <a:fontRef idx="minor">
+            <a:schemeClr val="lt1"/>
+          </a:fontRef>
+        </p:style>
+        <p:txBody>
+          <a:bodyPr rtlCol="0" anchor="ctr"/>
+          <a:lstStyle/>
+          <a:p>
+            <a:pPr algn="ctr"/>
+          </a:p>
+        </p:txBody>
+      </p:sp>
+      <p:sp>
+        <p:nvSpPr>
+          <p:cNvPr id="4" name="TextBox 3"/>
+          <p:cNvSpPr txBox="1"/>
+          <p:nvPr/>
+        </p:nvSpPr>
+        <p:spPr>
+          <a:xfrm>
+            <a:off x="777240" y="1417320"/>
+            <a:ext cx="10789920" cy="4297680"/>
+          </a:xfrm>
+          <a:prstGeom prst="rect">
+            <a:avLst/>
+          </a:prstGeom>
+          <a:noFill/>
+        </p:spPr>
+        <p:txBody>
+          <a:bodyPr wrap="none">
+            <a:spAutoFit/>
+          </a:bodyPr>
+          <a:lstStyle/>
+          <a:p>
+            <a:pPr>
+              <a:spcAft>
+                <a:spcPts val="800"/>
+              </a:spcAft>
+              <a:defRPr sz="1900">
+                <a:solidFill>
+                  <a:srgbClr val="282828"/>
+                </a:solidFill>
+                <a:latin typeface="Tahoma"/>
+              </a:defRPr>
+            </a:pPr>
+            <a:r>
+              <a:t>Endpoint หลัก: /predict รับไฟล์รูปภาพแบบ multipart/form-data</a:t>
+            </a:r>
+          </a:p>
+          <a:p>
+            <a:pPr>
+              <a:spcAft>
+                <a:spcPts val="800"/>
+              </a:spcAft>
+              <a:defRPr sz="1900">
+                <a:solidFill>
+                  <a:srgbClr val="282828"/>
+                </a:solidFill>
+                <a:latin typeface="Tahoma"/>
+              </a:defRPr>
+            </a:pPr>
+            <a:r>
+              <a:t>รองรับไฟล์ JPEG, PNG และ WebP</a:t>
+            </a:r>
+          </a:p>
+          <a:p>
+            <a:pPr>
+              <a:spcAft>
+                <a:spcPts val="800"/>
+              </a:spcAft>
+              <a:defRPr sz="1900">
+                <a:solidFill>
+                  <a:srgbClr val="282828"/>
+                </a:solidFill>
+                <a:latin typeface="Tahoma"/>
+              </a:defRPr>
+            </a:pPr>
+            <a:r>
+              <a:t>ตรวจสอบไฟล์ว่าง ไฟล์เสีย และขนาดไฟล์ก่อนเข้าโมเดล</a:t>
+            </a:r>
+          </a:p>
+          <a:p>
+            <a:pPr>
+              <a:spcAft>
+                <a:spcPts val="800"/>
+              </a:spcAft>
+              <a:defRPr sz="1900">
+                <a:solidFill>
+                  <a:srgbClr val="282828"/>
+                </a:solidFill>
+                <a:latin typeface="Tahoma"/>
+              </a:defRPr>
+            </a:pPr>
+            <a:r>
+              <a:t>ตอบกลับ 400 Bad Request เมื่อ input ไม่ถูกต้อง</a:t>
+            </a:r>
+          </a:p>
+          <a:p>
+            <a:pPr>
+              <a:spcAft>
+                <a:spcPts val="800"/>
+              </a:spcAft>
+              <a:defRPr sz="1900">
+                <a:solidFill>
+                  <a:srgbClr val="282828"/>
+                </a:solidFill>
+                <a:latin typeface="Tahoma"/>
+              </a:defRPr>
+            </a:pPr>
+            <a:r>
+              <a:t>ตอบกลับ 413 Request Entity Too Large เมื่อไฟล์ใหญ่เกินกำหนด</a:t>
+            </a:r>
+          </a:p>
+        </p:txBody>
+      </p:sp>
+      <p:sp>
+        <p:nvSpPr>
+          <p:cNvPr id="5" name="TextBox 4"/>
+          <p:cNvSpPr txBox="1"/>
+          <p:nvPr/>
+        </p:nvSpPr>
+        <p:spPr>
+          <a:xfrm>
+            <a:off x="9646920" y="6446520"/>
+            <a:ext cx="1920240" cy="228600"/>
+          </a:xfrm>
+          <a:prstGeom prst="rect">
+            <a:avLst/>
+          </a:prstGeom>
+          <a:noFill/>
+        </p:spPr>
+        <p:txBody>
+          <a:bodyPr wrap="none">
+            <a:spAutoFit/>
+          </a:bodyPr>
+          <a:lstStyle/>
+          <a:p>
+            <a:pPr algn="r"/>
+            <a:r>
+              <a:rPr sz="900" b="0">
+                <a:solidFill>
+                  <a:srgbClr val="595959"/>
+                </a:solidFill>
+                <a:latin typeface="Tahoma"/>
+              </a:rPr>
+              <a:t>MobileViT MLOps | 11</a:t>
+            </a:r>
+          </a:p>
+        </p:txBody>
+      </p:sp>
+    </p:spTree>
+  </p:cSld>
+  <p:clrMapOvr>
+    <a:masterClrMapping/>
+  </p:clrMapOvr>
+</p:sld>
+</file>
+
+<file path=ppt/slides/slide12.xml><?xml version="1.0" encoding="utf-8"?>
+<p:sld xmlns:a="http://schemas.openxmlformats.org/drawingml/2006/main" xmlns:p="http://schemas.openxmlformats.org/presentationml/2006/main" xmlns:r="http://schemas.openxmlformats.org/officeDocument/2006/relationships">
+  <p:cSld>
+    <p:spTree>
+      <p:nvGrpSpPr>
+        <p:cNvPr id="1" name=""/>
+        <p:cNvGrpSpPr/>
+        <p:nvPr/>
+      </p:nvGrpSpPr>
+      <p:grpSpPr/>
+      <p:sp>
+        <p:nvSpPr>
+          <p:cNvPr id="2" name="TextBox 1"/>
+          <p:cNvSpPr txBox="1"/>
+          <p:nvPr/>
+        </p:nvSpPr>
+        <p:spPr>
+          <a:xfrm>
+            <a:off x="594360" y="320040"/>
+            <a:ext cx="10972800" cy="640080"/>
+          </a:xfrm>
+          <a:prstGeom prst="rect">
+            <a:avLst/>
+          </a:prstGeom>
+          <a:noFill/>
+        </p:spPr>
+        <p:txBody>
+          <a:bodyPr wrap="none">
+            <a:spAutoFit/>
+          </a:bodyPr>
+          <a:lstStyle/>
+          <a:p>
+            <a:pPr algn="l"/>
+            <a:r>
+              <a:rPr sz="2800" b="1">
+                <a:solidFill>
+                  <a:srgbClr val="16365C"/>
+                </a:solidFill>
+                <a:latin typeface="Tahoma"/>
+              </a:rPr>
+              <a:t>ผลการทดสอบ API</a:t>
+            </a:r>
+          </a:p>
+        </p:txBody>
+      </p:sp>
+      <p:sp>
+        <p:nvSpPr>
+          <p:cNvPr id="3" name="Rectangle 2"/>
+          <p:cNvSpPr/>
+          <p:nvPr/>
+        </p:nvSpPr>
+        <p:spPr>
+          <a:xfrm>
+            <a:off x="594360" y="1024128"/>
+            <a:ext cx="10972800" cy="36576"/>
+          </a:xfrm>
+          <a:prstGeom prst="rect">
+            <a:avLst/>
+          </a:prstGeom>
+          <a:solidFill>
+            <a:srgbClr val="3275B5"/>
+          </a:solidFill>
+          <a:ln>
+            <a:noFill/>
+          </a:ln>
+        </p:spPr>
+        <p:style>
+          <a:lnRef idx="1">
+            <a:schemeClr val="accent1"/>
+          </a:lnRef>
+          <a:fillRef idx="3">
+            <a:schemeClr val="accent1"/>
+          </a:fillRef>
+          <a:effectRef idx="2">
+            <a:schemeClr val="accent1"/>
+          </a:effectRef>
+          <a:fontRef idx="minor">
+            <a:schemeClr val="lt1"/>
+          </a:fontRef>
+        </p:style>
+        <p:txBody>
+          <a:bodyPr rtlCol="0" anchor="ctr"/>
+          <a:lstStyle/>
+          <a:p>
+            <a:pPr algn="ctr"/>
+          </a:p>
+        </p:txBody>
+      </p:sp>
+      <p:sp>
+        <p:nvSpPr>
+          <p:cNvPr id="4" name="Rounded Rectangle 3"/>
+          <p:cNvSpPr/>
+          <p:nvPr/>
+        </p:nvSpPr>
+        <p:spPr>
+          <a:xfrm>
+            <a:off x="822960" y="1417320"/>
+            <a:ext cx="3200400" cy="1188720"/>
+          </a:xfrm>
+          <a:prstGeom prst="roundRect">
+            <a:avLst/>
+          </a:prstGeom>
+          <a:solidFill>
+            <a:srgbClr val="70AD47"/>
+          </a:solidFill>
+          <a:ln>
+            <a:solidFill>
+              <a:srgbClr val="B4B4B4"/>
+            </a:solidFill>
+          </a:ln>
+        </p:spPr>
+        <p:style>
+          <a:lnRef idx="1">
+            <a:schemeClr val="accent1"/>
+          </a:lnRef>
+          <a:fillRef idx="3">
+            <a:schemeClr val="accent1"/>
+          </a:fillRef>
+          <a:effectRef idx="2">
+            <a:schemeClr val="accent1"/>
+          </a:effectRef>
+          <a:fontRef idx="minor">
+            <a:schemeClr val="lt1"/>
+          </a:fontRef>
+        </p:style>
+        <p:txBody>
+          <a:bodyPr rtlCol="0" anchor="ctr"/>
+          <a:lstStyle/>
+          <a:p>
+            <a:pPr algn="ctr"/>
+          </a:p>
+        </p:txBody>
+      </p:sp>
+      <p:sp>
+        <p:nvSpPr>
+          <p:cNvPr id="5" name="TextBox 4"/>
+          <p:cNvSpPr txBox="1"/>
+          <p:nvPr/>
+        </p:nvSpPr>
+        <p:spPr>
+          <a:xfrm>
+            <a:off x="969264" y="1527048"/>
+            <a:ext cx="2907792" cy="1005840"/>
+          </a:xfrm>
+          <a:prstGeom prst="rect">
+            <a:avLst/>
+          </a:prstGeom>
+          <a:noFill/>
+        </p:spPr>
+        <p:txBody>
+          <a:bodyPr wrap="none">
+            <a:spAutoFit/>
+          </a:bodyPr>
+          <a:lstStyle/>
+          <a:p>
+            <a:r>
+              <a:rPr sz="1600" b="1">
+                <a:solidFill>
+                  <a:srgbClr val="16365C"/>
+                </a:solidFill>
+                <a:latin typeface="Tahoma"/>
+              </a:rPr>
+              <a:t>Unit Test</a:t>
+            </a:r>
+          </a:p>
+          <a:p>
+            <a:pPr>
+              <a:spcBef>
+                <a:spcPts val="500"/>
+              </a:spcBef>
+              <a:defRPr sz="1300">
+                <a:solidFill>
+                  <a:srgbClr val="282828"/>
+                </a:solidFill>
+                <a:latin typeface="Tahoma"/>
+              </a:defRPr>
+            </a:pPr>
+            <a:r>
+              <a:t>ผ่าน 3/3 tests</a:t>
+            </a:r>
+          </a:p>
+        </p:txBody>
+      </p:sp>
+      <p:sp>
+        <p:nvSpPr>
+          <p:cNvPr id="6" name="Rounded Rectangle 5"/>
+          <p:cNvSpPr/>
+          <p:nvPr/>
+        </p:nvSpPr>
+        <p:spPr>
+          <a:xfrm>
+            <a:off x="4480560" y="1417320"/>
+            <a:ext cx="3200400" cy="1188720"/>
+          </a:xfrm>
+          <a:prstGeom prst="roundRect">
+            <a:avLst/>
+          </a:prstGeom>
+          <a:solidFill>
+            <a:srgbClr val="70AD47"/>
+          </a:solidFill>
+          <a:ln>
+            <a:solidFill>
+              <a:srgbClr val="B4B4B4"/>
+            </a:solidFill>
+          </a:ln>
+        </p:spPr>
+        <p:style>
+          <a:lnRef idx="1">
+            <a:schemeClr val="accent1"/>
+          </a:lnRef>
+          <a:fillRef idx="3">
+            <a:schemeClr val="accent1"/>
+          </a:fillRef>
+          <a:effectRef idx="2">
+            <a:schemeClr val="accent1"/>
+          </a:effectRef>
+          <a:fontRef idx="minor">
+            <a:schemeClr val="lt1"/>
+          </a:fontRef>
+        </p:style>
+        <p:txBody>
+          <a:bodyPr rtlCol="0" anchor="ctr"/>
+          <a:lstStyle/>
+          <a:p>
+            <a:pPr algn="ctr"/>
+          </a:p>
+        </p:txBody>
+      </p:sp>
+      <p:sp>
+        <p:nvSpPr>
+          <p:cNvPr id="7" name="TextBox 6"/>
+          <p:cNvSpPr txBox="1"/>
+          <p:nvPr/>
+        </p:nvSpPr>
+        <p:spPr>
+          <a:xfrm>
+            <a:off x="4626864" y="1527048"/>
+            <a:ext cx="2907792" cy="1005840"/>
+          </a:xfrm>
+          <a:prstGeom prst="rect">
+            <a:avLst/>
+          </a:prstGeom>
+          <a:noFill/>
+        </p:spPr>
+        <p:txBody>
+          <a:bodyPr wrap="none">
+            <a:spAutoFit/>
+          </a:bodyPr>
+          <a:lstStyle/>
+          <a:p>
+            <a:r>
+              <a:rPr sz="1600" b="1">
+                <a:solidFill>
+                  <a:srgbClr val="16365C"/>
+                </a:solidFill>
+                <a:latin typeface="Tahoma"/>
+              </a:rPr>
+              <a:t>Docker Test</a:t>
+            </a:r>
+          </a:p>
+          <a:p>
+            <a:pPr>
+              <a:spcBef>
+                <a:spcPts val="500"/>
+              </a:spcBef>
+              <a:defRPr sz="1300">
+                <a:solidFill>
+                  <a:srgbClr val="282828"/>
+                </a:solidFill>
+                <a:latin typeface="Tahoma"/>
+              </a:defRPr>
+            </a:pPr>
+            <a:r>
+              <a:t>API รันและทำนายผลได้จริง</a:t>
+            </a:r>
+          </a:p>
+        </p:txBody>
+      </p:sp>
+      <p:sp>
+        <p:nvSpPr>
+          <p:cNvPr id="8" name="Rounded Rectangle 7"/>
+          <p:cNvSpPr/>
+          <p:nvPr/>
+        </p:nvSpPr>
+        <p:spPr>
+          <a:xfrm>
+            <a:off x="8138160" y="1417320"/>
+            <a:ext cx="3200400" cy="1188720"/>
+          </a:xfrm>
+          <a:prstGeom prst="roundRect">
+            <a:avLst/>
+          </a:prstGeom>
+          <a:solidFill>
+            <a:srgbClr val="70AD47"/>
+          </a:solidFill>
+          <a:ln>
+            <a:solidFill>
+              <a:srgbClr val="B4B4B4"/>
+            </a:solidFill>
+          </a:ln>
+        </p:spPr>
+        <p:style>
+          <a:lnRef idx="1">
+            <a:schemeClr val="accent1"/>
+          </a:lnRef>
+          <a:fillRef idx="3">
+            <a:schemeClr val="accent1"/>
+          </a:fillRef>
+          <a:effectRef idx="2">
+            <a:schemeClr val="accent1"/>
+          </a:effectRef>
+          <a:fontRef idx="minor">
+            <a:schemeClr val="lt1"/>
+          </a:fontRef>
+        </p:style>
+        <p:txBody>
+          <a:bodyPr rtlCol="0" anchor="ctr"/>
+          <a:lstStyle/>
+          <a:p>
+            <a:pPr algn="ctr"/>
+          </a:p>
+        </p:txBody>
+      </p:sp>
+      <p:sp>
+        <p:nvSpPr>
+          <p:cNvPr id="9" name="TextBox 8"/>
+          <p:cNvSpPr txBox="1"/>
+          <p:nvPr/>
+        </p:nvSpPr>
+        <p:spPr>
+          <a:xfrm>
+            <a:off x="8284464" y="1527048"/>
+            <a:ext cx="2907792" cy="1005840"/>
+          </a:xfrm>
+          <a:prstGeom prst="rect">
+            <a:avLst/>
+          </a:prstGeom>
+          <a:noFill/>
+        </p:spPr>
+        <p:txBody>
+          <a:bodyPr wrap="none">
+            <a:spAutoFit/>
+          </a:bodyPr>
+          <a:lstStyle/>
+          <a:p>
+            <a:r>
+              <a:rPr sz="1600" b="1">
+                <a:solidFill>
+                  <a:srgbClr val="16365C"/>
+                </a:solidFill>
+                <a:latin typeface="Tahoma"/>
+              </a:rPr>
+              <a:t>Prediction</a:t>
+            </a:r>
+          </a:p>
+          <a:p>
+            <a:pPr>
+              <a:spcBef>
+                <a:spcPts val="500"/>
+              </a:spcBef>
+              <a:defRPr sz="1300">
+                <a:solidFill>
+                  <a:srgbClr val="282828"/>
+                </a:solidFill>
+                <a:latin typeface="Tahoma"/>
+              </a:defRPr>
+            </a:pPr>
+            <a:r>
+              <a:t>runtime: onnx-quantized</a:t>
+            </a:r>
+          </a:p>
+        </p:txBody>
+      </p:sp>
+      <p:graphicFrame>
+        <p:nvGraphicFramePr>
+          <p:cNvPr id="10" name="Table 9"/>
+          <p:cNvGraphicFramePr>
+            <a:graphicFrameLocks noGrp="1"/>
+          </p:cNvGraphicFramePr>
+          <p:nvPr/>
+        </p:nvGraphicFramePr>
+        <p:xfrm>
+          <a:off x="1097280" y="3291840"/>
+          <a:ext cx="9875520" cy="1143000"/>
+        </p:xfrm>
+        <a:graphic>
+          <a:graphicData uri="http://schemas.openxmlformats.org/drawingml/2006/table">
+            <a:tbl>
+              <a:tblPr firstRow="1" bandRow="1">
+                <a:tableStyleId>{5C22544A-7EE6-4342-B048-85BDC9FD1C3A}</a:tableStyleId>
+              </a:tblPr>
+              <a:tblGrid>
+                <a:gridCol w="4937760"/>
+                <a:gridCol w="4937760"/>
+              </a:tblGrid>
+              <a:tr h="381000">
+                <a:tc>
+                  <a:txBody>
+                    <a:bodyPr/>
+                    <a:lstStyle/>
+                    <a:p>
+                      <a:pPr algn="ctr"/>
+                      <a:r>
+                        <a:rPr sz="1200" b="1">
+                          <a:solidFill>
+                            <a:srgbClr val="FFFFFF"/>
+                          </a:solidFill>
+                          <a:latin typeface="Tahoma"/>
+                        </a:rPr>
+                        <a:t>Input</a:t>
+                      </a:r>
+                    </a:p>
+                  </a:txBody>
+                  <a:tcPr>
+                    <a:solidFill>
+                      <a:srgbClr val="3275B5"/>
+                    </a:solidFill>
+                  </a:tcPr>
+                </a:tc>
+                <a:tc>
+                  <a:txBody>
+                    <a:bodyPr/>
+                    <a:lstStyle/>
+                    <a:p>
+                      <a:pPr algn="ctr"/>
+                      <a:r>
+                        <a:rPr sz="1200" b="1">
+                          <a:solidFill>
+                            <a:srgbClr val="FFFFFF"/>
+                          </a:solidFill>
+                          <a:latin typeface="Tahoma"/>
+                        </a:rPr>
+                        <a:t>ผลลัพธ์</a:t>
+                      </a:r>
+                    </a:p>
+                  </a:txBody>
+                  <a:tcPr>
+                    <a:solidFill>
+                      <a:srgbClr val="3275B5"/>
+                    </a:solidFill>
+                  </a:tcPr>
+                </a:tc>
+              </a:tr>
+              <a:tr h="381000">
+                <a:tc>
+                  <a:txBody>
+                    <a:bodyPr/>
+                    <a:lstStyle/>
+                    <a:p>
+                      <a:pPr algn="ctr"/>
+                      <a:r>
+                        <a:rPr sz="1200" b="0">
+                          <a:solidFill>
+                            <a:srgbClr val="282828"/>
+                          </a:solidFill>
+                          <a:latin typeface="Tahoma"/>
+                        </a:rPr>
+                        <a:t>sample_images/benchmark.png</a:t>
+                      </a:r>
+                    </a:p>
+                  </a:txBody>
+                  <a:tcPr/>
+                </a:tc>
+                <a:tc>
+                  <a:txBody>
+                    <a:bodyPr/>
+                    <a:lstStyle/>
+                    <a:p>
+                      <a:pPr algn="ctr"/>
+                      <a:r>
+                        <a:rPr sz="1200" b="0">
+                          <a:solidFill>
+                            <a:srgbClr val="282828"/>
+                          </a:solidFill>
+                          <a:latin typeface="Tahoma"/>
+                        </a:rPr>
+                        <a:t>tabby cat, Egyptian cat, tiger cat</a:t>
+                      </a:r>
+                    </a:p>
+                  </a:txBody>
+                  <a:tcPr/>
+                </a:tc>
+              </a:tr>
+              <a:tr h="381000">
+                <a:tc>
+                  <a:txBody>
+                    <a:bodyPr/>
+                    <a:lstStyle/>
+                    <a:p>
+                      <a:pPr algn="ctr"/>
+                      <a:r>
+                        <a:rPr sz="1200" b="0">
+                          <a:solidFill>
+                            <a:srgbClr val="282828"/>
+                          </a:solidFill>
+                          <a:latin typeface="Tahoma"/>
+                        </a:rPr>
+                        <a:t>ไฟล์ text/plain</a:t>
+                      </a:r>
+                    </a:p>
+                  </a:txBody>
+                  <a:tcPr/>
+                </a:tc>
+                <a:tc>
+                  <a:txBody>
+                    <a:bodyPr/>
+                    <a:lstStyle/>
+                    <a:p>
+                      <a:pPr algn="ctr"/>
+                      <a:r>
+                        <a:rPr sz="1200" b="0">
+                          <a:solidFill>
+                            <a:srgbClr val="282828"/>
+                          </a:solidFill>
+                          <a:latin typeface="Tahoma"/>
+                        </a:rPr>
+                        <a:t>400 Bad Request</a:t>
+                      </a:r>
+                    </a:p>
+                  </a:txBody>
+                  <a:tcPr/>
+                </a:tc>
+              </a:tr>
+            </a:tbl>
+          </a:graphicData>
+        </a:graphic>
+      </p:graphicFrame>
+      <p:sp>
+        <p:nvSpPr>
+          <p:cNvPr id="11" name="TextBox 10"/>
+          <p:cNvSpPr txBox="1"/>
+          <p:nvPr/>
+        </p:nvSpPr>
+        <p:spPr>
+          <a:xfrm>
+            <a:off x="9646920" y="6446520"/>
+            <a:ext cx="1920240" cy="228600"/>
+          </a:xfrm>
+          <a:prstGeom prst="rect">
+            <a:avLst/>
+          </a:prstGeom>
+          <a:noFill/>
+        </p:spPr>
+        <p:txBody>
+          <a:bodyPr wrap="none">
+            <a:spAutoFit/>
+          </a:bodyPr>
+          <a:lstStyle/>
+          <a:p>
+            <a:pPr algn="r"/>
+            <a:r>
+              <a:rPr sz="900" b="0">
+                <a:solidFill>
+                  <a:srgbClr val="595959"/>
+                </a:solidFill>
+                <a:latin typeface="Tahoma"/>
+              </a:rPr>
+              <a:t>MobileViT MLOps | 12</a:t>
+            </a:r>
+          </a:p>
+        </p:txBody>
+      </p:sp>
+    </p:spTree>
+  </p:cSld>
+  <p:clrMapOvr>
+    <a:masterClrMapping/>
+  </p:clrMapOvr>
+</p:sld>
+</file>
+
+<file path=ppt/slides/slide13.xml><?xml version="1.0" encoding="utf-8"?>
 <p:sld xmlns:a="http://schemas.openxmlformats.org/drawingml/2006/main" xmlns:p="http://schemas.openxmlformats.org/presentationml/2006/main" xmlns:r="http://schemas.openxmlformats.org/officeDocument/2006/relationships">
   <p:cSld>
     <p:spTree>
@@ -3839,1442 +4880,6 @@
                 </a:solidFill>
                 <a:latin typeface="Tahoma"/>
               </a:rPr>
-              <a:t>MobileViT MLOps | 10</a:t>
-            </a:r>
-          </a:p>
-        </p:txBody>
-      </p:sp>
-    </p:spTree>
-  </p:cSld>
-  <p:clrMapOvr>
-    <a:masterClrMapping/>
-  </p:clrMapOvr>
-</p:sld>
-</file>
-
-<file path=ppt/slides/slide11.xml><?xml version="1.0" encoding="utf-8"?>
-<p:sld xmlns:a="http://schemas.openxmlformats.org/drawingml/2006/main" xmlns:p="http://schemas.openxmlformats.org/presentationml/2006/main" xmlns:r="http://schemas.openxmlformats.org/officeDocument/2006/relationships">
-  <p:cSld>
-    <p:spTree>
-      <p:nvGrpSpPr>
-        <p:cNvPr id="1" name=""/>
-        <p:cNvGrpSpPr/>
-        <p:nvPr/>
-      </p:nvGrpSpPr>
-      <p:grpSpPr/>
-      <p:sp>
-        <p:nvSpPr>
-          <p:cNvPr id="2" name="TextBox 1"/>
-          <p:cNvSpPr txBox="1"/>
-          <p:nvPr/>
-        </p:nvSpPr>
-        <p:spPr>
-          <a:xfrm>
-            <a:off x="594360" y="320040"/>
-            <a:ext cx="10972800" cy="640080"/>
-          </a:xfrm>
-          <a:prstGeom prst="rect">
-            <a:avLst/>
-          </a:prstGeom>
-          <a:noFill/>
-        </p:spPr>
-        <p:txBody>
-          <a:bodyPr wrap="none">
-            <a:spAutoFit/>
-          </a:bodyPr>
-          <a:lstStyle/>
-          <a:p>
-            <a:pPr algn="l"/>
-            <a:r>
-              <a:rPr sz="2800" b="1">
-                <a:solidFill>
-                  <a:srgbClr val="16365C"/>
-                </a:solidFill>
-                <a:latin typeface="Tahoma"/>
-              </a:rPr>
-              <a:t>CI/CD Pipeline</a:t>
-            </a:r>
-          </a:p>
-        </p:txBody>
-      </p:sp>
-      <p:sp>
-        <p:nvSpPr>
-          <p:cNvPr id="3" name="Rectangle 2"/>
-          <p:cNvSpPr/>
-          <p:nvPr/>
-        </p:nvSpPr>
-        <p:spPr>
-          <a:xfrm>
-            <a:off x="594360" y="1024128"/>
-            <a:ext cx="10972800" cy="36576"/>
-          </a:xfrm>
-          <a:prstGeom prst="rect">
-            <a:avLst/>
-          </a:prstGeom>
-          <a:solidFill>
-            <a:srgbClr val="3275B5"/>
-          </a:solidFill>
-          <a:ln>
-            <a:noFill/>
-          </a:ln>
-        </p:spPr>
-        <p:style>
-          <a:lnRef idx="1">
-            <a:schemeClr val="accent1"/>
-          </a:lnRef>
-          <a:fillRef idx="3">
-            <a:schemeClr val="accent1"/>
-          </a:fillRef>
-          <a:effectRef idx="2">
-            <a:schemeClr val="accent1"/>
-          </a:effectRef>
-          <a:fontRef idx="minor">
-            <a:schemeClr val="lt1"/>
-          </a:fontRef>
-        </p:style>
-        <p:txBody>
-          <a:bodyPr rtlCol="0" anchor="ctr"/>
-          <a:lstStyle/>
-          <a:p>
-            <a:pPr algn="ctr"/>
-          </a:p>
-        </p:txBody>
-      </p:sp>
-      <p:sp>
-        <p:nvSpPr>
-          <p:cNvPr id="4" name="Rounded Rectangle 3"/>
-          <p:cNvSpPr/>
-          <p:nvPr/>
-        </p:nvSpPr>
-        <p:spPr>
-          <a:xfrm>
-            <a:off x="914400" y="1691640"/>
-            <a:ext cx="2057400" cy="1097280"/>
-          </a:xfrm>
-          <a:prstGeom prst="roundRect">
-            <a:avLst/>
-          </a:prstGeom>
-          <a:solidFill>
-            <a:srgbClr val="E8F2FA"/>
-          </a:solidFill>
-          <a:ln>
-            <a:solidFill>
-              <a:srgbClr val="B4B4B4"/>
-            </a:solidFill>
-          </a:ln>
-        </p:spPr>
-        <p:style>
-          <a:lnRef idx="1">
-            <a:schemeClr val="accent1"/>
-          </a:lnRef>
-          <a:fillRef idx="3">
-            <a:schemeClr val="accent1"/>
-          </a:fillRef>
-          <a:effectRef idx="2">
-            <a:schemeClr val="accent1"/>
-          </a:effectRef>
-          <a:fontRef idx="minor">
-            <a:schemeClr val="lt1"/>
-          </a:fontRef>
-        </p:style>
-        <p:txBody>
-          <a:bodyPr rtlCol="0" anchor="ctr"/>
-          <a:lstStyle/>
-          <a:p>
-            <a:pPr algn="ctr"/>
-          </a:p>
-        </p:txBody>
-      </p:sp>
-      <p:sp>
-        <p:nvSpPr>
-          <p:cNvPr id="5" name="TextBox 4"/>
-          <p:cNvSpPr txBox="1"/>
-          <p:nvPr/>
-        </p:nvSpPr>
-        <p:spPr>
-          <a:xfrm>
-            <a:off x="1060704" y="1801368"/>
-            <a:ext cx="1764792" cy="914400"/>
-          </a:xfrm>
-          <a:prstGeom prst="rect">
-            <a:avLst/>
-          </a:prstGeom>
-          <a:noFill/>
-        </p:spPr>
-        <p:txBody>
-          <a:bodyPr wrap="none">
-            <a:spAutoFit/>
-          </a:bodyPr>
-          <a:lstStyle/>
-          <a:p>
-            <a:r>
-              <a:rPr sz="1600" b="1">
-                <a:solidFill>
-                  <a:srgbClr val="16365C"/>
-                </a:solidFill>
-                <a:latin typeface="Tahoma"/>
-              </a:rPr>
-              <a:t>Push Code</a:t>
-            </a:r>
-          </a:p>
-          <a:p>
-            <a:pPr>
-              <a:spcBef>
-                <a:spcPts val="500"/>
-              </a:spcBef>
-              <a:defRPr sz="1300">
-                <a:solidFill>
-                  <a:srgbClr val="282828"/>
-                </a:solidFill>
-                <a:latin typeface="Tahoma"/>
-              </a:defRPr>
-            </a:pPr>
-            <a:r>
-              <a:t>GitHub</a:t>
-            </a:r>
-          </a:p>
-        </p:txBody>
-      </p:sp>
-      <p:sp>
-        <p:nvSpPr>
-          <p:cNvPr id="6" name="Right Arrow 5"/>
-          <p:cNvSpPr/>
-          <p:nvPr/>
-        </p:nvSpPr>
-        <p:spPr>
-          <a:xfrm>
-            <a:off x="3035808" y="2148840"/>
-            <a:ext cx="411480" cy="210312"/>
-          </a:xfrm>
-          <a:prstGeom prst="rightArrow">
-            <a:avLst/>
-          </a:prstGeom>
-          <a:solidFill>
-            <a:srgbClr val="3275B5"/>
-          </a:solidFill>
-          <a:ln>
-            <a:noFill/>
-          </a:ln>
-        </p:spPr>
-        <p:style>
-          <a:lnRef idx="1">
-            <a:schemeClr val="accent1"/>
-          </a:lnRef>
-          <a:fillRef idx="3">
-            <a:schemeClr val="accent1"/>
-          </a:fillRef>
-          <a:effectRef idx="2">
-            <a:schemeClr val="accent1"/>
-          </a:effectRef>
-          <a:fontRef idx="minor">
-            <a:schemeClr val="lt1"/>
-          </a:fontRef>
-        </p:style>
-        <p:txBody>
-          <a:bodyPr rtlCol="0" anchor="ctr"/>
-          <a:lstStyle/>
-          <a:p>
-            <a:pPr algn="ctr"/>
-          </a:p>
-        </p:txBody>
-      </p:sp>
-      <p:sp>
-        <p:nvSpPr>
-          <p:cNvPr id="7" name="Rounded Rectangle 6"/>
-          <p:cNvSpPr/>
-          <p:nvPr/>
-        </p:nvSpPr>
-        <p:spPr>
-          <a:xfrm>
-            <a:off x="3474720" y="1691640"/>
-            <a:ext cx="2057400" cy="1097280"/>
-          </a:xfrm>
-          <a:prstGeom prst="roundRect">
-            <a:avLst/>
-          </a:prstGeom>
-          <a:solidFill>
-            <a:srgbClr val="E8F2FA"/>
-          </a:solidFill>
-          <a:ln>
-            <a:solidFill>
-              <a:srgbClr val="B4B4B4"/>
-            </a:solidFill>
-          </a:ln>
-        </p:spPr>
-        <p:style>
-          <a:lnRef idx="1">
-            <a:schemeClr val="accent1"/>
-          </a:lnRef>
-          <a:fillRef idx="3">
-            <a:schemeClr val="accent1"/>
-          </a:fillRef>
-          <a:effectRef idx="2">
-            <a:schemeClr val="accent1"/>
-          </a:effectRef>
-          <a:fontRef idx="minor">
-            <a:schemeClr val="lt1"/>
-          </a:fontRef>
-        </p:style>
-        <p:txBody>
-          <a:bodyPr rtlCol="0" anchor="ctr"/>
-          <a:lstStyle/>
-          <a:p>
-            <a:pPr algn="ctr"/>
-          </a:p>
-        </p:txBody>
-      </p:sp>
-      <p:sp>
-        <p:nvSpPr>
-          <p:cNvPr id="8" name="TextBox 7"/>
-          <p:cNvSpPr txBox="1"/>
-          <p:nvPr/>
-        </p:nvSpPr>
-        <p:spPr>
-          <a:xfrm>
-            <a:off x="3621024" y="1801368"/>
-            <a:ext cx="1764792" cy="914400"/>
-          </a:xfrm>
-          <a:prstGeom prst="rect">
-            <a:avLst/>
-          </a:prstGeom>
-          <a:noFill/>
-        </p:spPr>
-        <p:txBody>
-          <a:bodyPr wrap="none">
-            <a:spAutoFit/>
-          </a:bodyPr>
-          <a:lstStyle/>
-          <a:p>
-            <a:r>
-              <a:rPr sz="1600" b="1">
-                <a:solidFill>
-                  <a:srgbClr val="16365C"/>
-                </a:solidFill>
-                <a:latin typeface="Tahoma"/>
-              </a:rPr>
-              <a:t>Install</a:t>
-            </a:r>
-          </a:p>
-          <a:p>
-            <a:pPr>
-              <a:spcBef>
-                <a:spcPts val="500"/>
-              </a:spcBef>
-              <a:defRPr sz="1300">
-                <a:solidFill>
-                  <a:srgbClr val="282828"/>
-                </a:solidFill>
-                <a:latin typeface="Tahoma"/>
-              </a:defRPr>
-            </a:pPr>
-            <a:r>
-              <a:t>Dependencies</a:t>
-            </a:r>
-          </a:p>
-        </p:txBody>
-      </p:sp>
-      <p:sp>
-        <p:nvSpPr>
-          <p:cNvPr id="9" name="Right Arrow 8"/>
-          <p:cNvSpPr/>
-          <p:nvPr/>
-        </p:nvSpPr>
-        <p:spPr>
-          <a:xfrm>
-            <a:off x="5596127" y="2148840"/>
-            <a:ext cx="411480" cy="210312"/>
-          </a:xfrm>
-          <a:prstGeom prst="rightArrow">
-            <a:avLst/>
-          </a:prstGeom>
-          <a:solidFill>
-            <a:srgbClr val="3275B5"/>
-          </a:solidFill>
-          <a:ln>
-            <a:noFill/>
-          </a:ln>
-        </p:spPr>
-        <p:style>
-          <a:lnRef idx="1">
-            <a:schemeClr val="accent1"/>
-          </a:lnRef>
-          <a:fillRef idx="3">
-            <a:schemeClr val="accent1"/>
-          </a:fillRef>
-          <a:effectRef idx="2">
-            <a:schemeClr val="accent1"/>
-          </a:effectRef>
-          <a:fontRef idx="minor">
-            <a:schemeClr val="lt1"/>
-          </a:fontRef>
-        </p:style>
-        <p:txBody>
-          <a:bodyPr rtlCol="0" anchor="ctr"/>
-          <a:lstStyle/>
-          <a:p>
-            <a:pPr algn="ctr"/>
-          </a:p>
-        </p:txBody>
-      </p:sp>
-      <p:sp>
-        <p:nvSpPr>
-          <p:cNvPr id="10" name="Rounded Rectangle 9"/>
-          <p:cNvSpPr/>
-          <p:nvPr/>
-        </p:nvSpPr>
-        <p:spPr>
-          <a:xfrm>
-            <a:off x="6035040" y="1691640"/>
-            <a:ext cx="2057400" cy="1097280"/>
-          </a:xfrm>
-          <a:prstGeom prst="roundRect">
-            <a:avLst/>
-          </a:prstGeom>
-          <a:solidFill>
-            <a:srgbClr val="E8F2FA"/>
-          </a:solidFill>
-          <a:ln>
-            <a:solidFill>
-              <a:srgbClr val="B4B4B4"/>
-            </a:solidFill>
-          </a:ln>
-        </p:spPr>
-        <p:style>
-          <a:lnRef idx="1">
-            <a:schemeClr val="accent1"/>
-          </a:lnRef>
-          <a:fillRef idx="3">
-            <a:schemeClr val="accent1"/>
-          </a:fillRef>
-          <a:effectRef idx="2">
-            <a:schemeClr val="accent1"/>
-          </a:effectRef>
-          <a:fontRef idx="minor">
-            <a:schemeClr val="lt1"/>
-          </a:fontRef>
-        </p:style>
-        <p:txBody>
-          <a:bodyPr rtlCol="0" anchor="ctr"/>
-          <a:lstStyle/>
-          <a:p>
-            <a:pPr algn="ctr"/>
-          </a:p>
-        </p:txBody>
-      </p:sp>
-      <p:sp>
-        <p:nvSpPr>
-          <p:cNvPr id="11" name="TextBox 10"/>
-          <p:cNvSpPr txBox="1"/>
-          <p:nvPr/>
-        </p:nvSpPr>
-        <p:spPr>
-          <a:xfrm>
-            <a:off x="6181344" y="1801368"/>
-            <a:ext cx="1764792" cy="914400"/>
-          </a:xfrm>
-          <a:prstGeom prst="rect">
-            <a:avLst/>
-          </a:prstGeom>
-          <a:noFill/>
-        </p:spPr>
-        <p:txBody>
-          <a:bodyPr wrap="none">
-            <a:spAutoFit/>
-          </a:bodyPr>
-          <a:lstStyle/>
-          <a:p>
-            <a:r>
-              <a:rPr sz="1600" b="1">
-                <a:solidFill>
-                  <a:srgbClr val="16365C"/>
-                </a:solidFill>
-                <a:latin typeface="Tahoma"/>
-              </a:rPr>
-              <a:t>Test</a:t>
-            </a:r>
-          </a:p>
-          <a:p>
-            <a:pPr>
-              <a:spcBef>
-                <a:spcPts val="500"/>
-              </a:spcBef>
-              <a:defRPr sz="1300">
-                <a:solidFill>
-                  <a:srgbClr val="282828"/>
-                </a:solidFill>
-                <a:latin typeface="Tahoma"/>
-              </a:defRPr>
-            </a:pPr>
-            <a:r>
-              <a:t>pytest</a:t>
-            </a:r>
-          </a:p>
-        </p:txBody>
-      </p:sp>
-      <p:sp>
-        <p:nvSpPr>
-          <p:cNvPr id="12" name="Right Arrow 11"/>
-          <p:cNvSpPr/>
-          <p:nvPr/>
-        </p:nvSpPr>
-        <p:spPr>
-          <a:xfrm>
-            <a:off x="8156448" y="2148840"/>
-            <a:ext cx="411480" cy="210312"/>
-          </a:xfrm>
-          <a:prstGeom prst="rightArrow">
-            <a:avLst/>
-          </a:prstGeom>
-          <a:solidFill>
-            <a:srgbClr val="3275B5"/>
-          </a:solidFill>
-          <a:ln>
-            <a:noFill/>
-          </a:ln>
-        </p:spPr>
-        <p:style>
-          <a:lnRef idx="1">
-            <a:schemeClr val="accent1"/>
-          </a:lnRef>
-          <a:fillRef idx="3">
-            <a:schemeClr val="accent1"/>
-          </a:fillRef>
-          <a:effectRef idx="2">
-            <a:schemeClr val="accent1"/>
-          </a:effectRef>
-          <a:fontRef idx="minor">
-            <a:schemeClr val="lt1"/>
-          </a:fontRef>
-        </p:style>
-        <p:txBody>
-          <a:bodyPr rtlCol="0" anchor="ctr"/>
-          <a:lstStyle/>
-          <a:p>
-            <a:pPr algn="ctr"/>
-          </a:p>
-        </p:txBody>
-      </p:sp>
-      <p:sp>
-        <p:nvSpPr>
-          <p:cNvPr id="13" name="Rounded Rectangle 12"/>
-          <p:cNvSpPr/>
-          <p:nvPr/>
-        </p:nvSpPr>
-        <p:spPr>
-          <a:xfrm>
-            <a:off x="8595359" y="1691640"/>
-            <a:ext cx="2057400" cy="1097280"/>
-          </a:xfrm>
-          <a:prstGeom prst="roundRect">
-            <a:avLst/>
-          </a:prstGeom>
-          <a:solidFill>
-            <a:srgbClr val="E8F2FA"/>
-          </a:solidFill>
-          <a:ln>
-            <a:solidFill>
-              <a:srgbClr val="B4B4B4"/>
-            </a:solidFill>
-          </a:ln>
-        </p:spPr>
-        <p:style>
-          <a:lnRef idx="1">
-            <a:schemeClr val="accent1"/>
-          </a:lnRef>
-          <a:fillRef idx="3">
-            <a:schemeClr val="accent1"/>
-          </a:fillRef>
-          <a:effectRef idx="2">
-            <a:schemeClr val="accent1"/>
-          </a:effectRef>
-          <a:fontRef idx="minor">
-            <a:schemeClr val="lt1"/>
-          </a:fontRef>
-        </p:style>
-        <p:txBody>
-          <a:bodyPr rtlCol="0" anchor="ctr"/>
-          <a:lstStyle/>
-          <a:p>
-            <a:pPr algn="ctr"/>
-          </a:p>
-        </p:txBody>
-      </p:sp>
-      <p:sp>
-        <p:nvSpPr>
-          <p:cNvPr id="14" name="TextBox 13"/>
-          <p:cNvSpPr txBox="1"/>
-          <p:nvPr/>
-        </p:nvSpPr>
-        <p:spPr>
-          <a:xfrm>
-            <a:off x="8741663" y="1801368"/>
-            <a:ext cx="1764792" cy="914400"/>
-          </a:xfrm>
-          <a:prstGeom prst="rect">
-            <a:avLst/>
-          </a:prstGeom>
-          <a:noFill/>
-        </p:spPr>
-        <p:txBody>
-          <a:bodyPr wrap="none">
-            <a:spAutoFit/>
-          </a:bodyPr>
-          <a:lstStyle/>
-          <a:p>
-            <a:r>
-              <a:rPr sz="1600" b="1">
-                <a:solidFill>
-                  <a:srgbClr val="16365C"/>
-                </a:solidFill>
-                <a:latin typeface="Tahoma"/>
-              </a:rPr>
-              <a:t>Deploy</a:t>
-            </a:r>
-          </a:p>
-          <a:p>
-            <a:pPr>
-              <a:spcBef>
-                <a:spcPts val="500"/>
-              </a:spcBef>
-              <a:defRPr sz="1300">
-                <a:solidFill>
-                  <a:srgbClr val="282828"/>
-                </a:solidFill>
-                <a:latin typeface="Tahoma"/>
-              </a:defRPr>
-            </a:pPr>
-            <a:r>
-              <a:t>Hugging Face Spaces</a:t>
-            </a:r>
-          </a:p>
-        </p:txBody>
-      </p:sp>
-      <p:sp>
-        <p:nvSpPr>
-          <p:cNvPr id="15" name="TextBox 14"/>
-          <p:cNvSpPr txBox="1"/>
-          <p:nvPr/>
-        </p:nvSpPr>
-        <p:spPr>
-          <a:xfrm>
-            <a:off x="777240" y="3794760"/>
-            <a:ext cx="10789920" cy="4297680"/>
-          </a:xfrm>
-          <a:prstGeom prst="rect">
-            <a:avLst/>
-          </a:prstGeom>
-          <a:noFill/>
-        </p:spPr>
-        <p:txBody>
-          <a:bodyPr wrap="none">
-            <a:spAutoFit/>
-          </a:bodyPr>
-          <a:lstStyle/>
-          <a:p>
-            <a:pPr>
-              <a:spcAft>
-                <a:spcPts val="800"/>
-              </a:spcAft>
-              <a:defRPr sz="1800">
-                <a:solidFill>
-                  <a:srgbClr val="282828"/>
-                </a:solidFill>
-                <a:latin typeface="Tahoma"/>
-              </a:defRPr>
-            </a:pPr>
-            <a:r>
-              <a:t>Workflow อยู่ที่ .github/workflows/ci-cd.yml</a:t>
-            </a:r>
-          </a:p>
-          <a:p>
-            <a:pPr>
-              <a:spcAft>
-                <a:spcPts val="800"/>
-              </a:spcAft>
-              <a:defRPr sz="1800">
-                <a:solidFill>
-                  <a:srgbClr val="282828"/>
-                </a:solidFill>
-                <a:latin typeface="Tahoma"/>
-              </a:defRPr>
-            </a:pPr>
-            <a:r>
-              <a:t>รัน unit test ทุกครั้งที่ push หรือ pull request ไปยัง main</a:t>
-            </a:r>
-          </a:p>
-          <a:p>
-            <a:pPr>
-              <a:spcAft>
-                <a:spcPts val="800"/>
-              </a:spcAft>
-              <a:defRPr sz="1800">
-                <a:solidFill>
-                  <a:srgbClr val="282828"/>
-                </a:solidFill>
-                <a:latin typeface="Tahoma"/>
-              </a:defRPr>
-            </a:pPr>
-            <a:r>
-              <a:t>รองรับ auto-deploy เมื่อกำหนด HF_TOKEN และ HF_SPACE_REPO_ID</a:t>
-            </a:r>
-          </a:p>
-        </p:txBody>
-      </p:sp>
-      <p:sp>
-        <p:nvSpPr>
-          <p:cNvPr id="16" name="TextBox 15"/>
-          <p:cNvSpPr txBox="1"/>
-          <p:nvPr/>
-        </p:nvSpPr>
-        <p:spPr>
-          <a:xfrm>
-            <a:off x="9646920" y="6446520"/>
-            <a:ext cx="1920240" cy="228600"/>
-          </a:xfrm>
-          <a:prstGeom prst="rect">
-            <a:avLst/>
-          </a:prstGeom>
-          <a:noFill/>
-        </p:spPr>
-        <p:txBody>
-          <a:bodyPr wrap="none">
-            <a:spAutoFit/>
-          </a:bodyPr>
-          <a:lstStyle/>
-          <a:p>
-            <a:pPr algn="r"/>
-            <a:r>
-              <a:rPr sz="900" b="0">
-                <a:solidFill>
-                  <a:srgbClr val="595959"/>
-                </a:solidFill>
-                <a:latin typeface="Tahoma"/>
-              </a:rPr>
-              <a:t>MobileViT MLOps | 11</a:t>
-            </a:r>
-          </a:p>
-        </p:txBody>
-      </p:sp>
-    </p:spTree>
-  </p:cSld>
-  <p:clrMapOvr>
-    <a:masterClrMapping/>
-  </p:clrMapOvr>
-</p:sld>
-</file>
-
-<file path=ppt/slides/slide12.xml><?xml version="1.0" encoding="utf-8"?>
-<p:sld xmlns:a="http://schemas.openxmlformats.org/drawingml/2006/main" xmlns:p="http://schemas.openxmlformats.org/presentationml/2006/main" xmlns:r="http://schemas.openxmlformats.org/officeDocument/2006/relationships">
-  <p:cSld>
-    <p:spTree>
-      <p:nvGrpSpPr>
-        <p:cNvPr id="1" name=""/>
-        <p:cNvGrpSpPr/>
-        <p:nvPr/>
-      </p:nvGrpSpPr>
-      <p:grpSpPr/>
-      <p:sp>
-        <p:nvSpPr>
-          <p:cNvPr id="2" name="TextBox 1"/>
-          <p:cNvSpPr txBox="1"/>
-          <p:nvPr/>
-        </p:nvSpPr>
-        <p:spPr>
-          <a:xfrm>
-            <a:off x="594360" y="320040"/>
-            <a:ext cx="10972800" cy="640080"/>
-          </a:xfrm>
-          <a:prstGeom prst="rect">
-            <a:avLst/>
-          </a:prstGeom>
-          <a:noFill/>
-        </p:spPr>
-        <p:txBody>
-          <a:bodyPr wrap="none">
-            <a:spAutoFit/>
-          </a:bodyPr>
-          <a:lstStyle/>
-          <a:p>
-            <a:pPr algn="l"/>
-            <a:r>
-              <a:rPr sz="2800" b="1">
-                <a:solidFill>
-                  <a:srgbClr val="16365C"/>
-                </a:solidFill>
-                <a:latin typeface="Tahoma"/>
-              </a:rPr>
-              <a:t>Live Demo: API บน Docker</a:t>
-            </a:r>
-          </a:p>
-        </p:txBody>
-      </p:sp>
-      <p:sp>
-        <p:nvSpPr>
-          <p:cNvPr id="3" name="Rectangle 2"/>
-          <p:cNvSpPr/>
-          <p:nvPr/>
-        </p:nvSpPr>
-        <p:spPr>
-          <a:xfrm>
-            <a:off x="594360" y="1024128"/>
-            <a:ext cx="10972800" cy="36576"/>
-          </a:xfrm>
-          <a:prstGeom prst="rect">
-            <a:avLst/>
-          </a:prstGeom>
-          <a:solidFill>
-            <a:srgbClr val="3275B5"/>
-          </a:solidFill>
-          <a:ln>
-            <a:noFill/>
-          </a:ln>
-        </p:spPr>
-        <p:style>
-          <a:lnRef idx="1">
-            <a:schemeClr val="accent1"/>
-          </a:lnRef>
-          <a:fillRef idx="3">
-            <a:schemeClr val="accent1"/>
-          </a:fillRef>
-          <a:effectRef idx="2">
-            <a:schemeClr val="accent1"/>
-          </a:effectRef>
-          <a:fontRef idx="minor">
-            <a:schemeClr val="lt1"/>
-          </a:fontRef>
-        </p:style>
-        <p:txBody>
-          <a:bodyPr rtlCol="0" anchor="ctr"/>
-          <a:lstStyle/>
-          <a:p>
-            <a:pPr algn="ctr"/>
-          </a:p>
-        </p:txBody>
-      </p:sp>
-      <p:pic>
-        <p:nvPicPr>
-          <p:cNvPr id="4" name="Picture 3" descr="benchmark.png"/>
-          <p:cNvPicPr>
-            <a:picLocks noChangeAspect="1"/>
-          </p:cNvPicPr>
-          <p:nvPr/>
-        </p:nvPicPr>
-        <p:blipFill>
-          <a:blip r:embed="rId2"/>
-          <a:stretch>
-            <a:fillRect/>
-          </a:stretch>
-        </p:blipFill>
-        <p:spPr>
-          <a:xfrm>
-            <a:off x="822960" y="1417320"/>
-            <a:ext cx="3931920" cy="2604423"/>
-          </a:xfrm>
-          <a:prstGeom prst="rect">
-            <a:avLst/>
-          </a:prstGeom>
-        </p:spPr>
-      </p:pic>
-      <p:sp>
-        <p:nvSpPr>
-          <p:cNvPr id="5" name="TextBox 4"/>
-          <p:cNvSpPr txBox="1"/>
-          <p:nvPr/>
-        </p:nvSpPr>
-        <p:spPr>
-          <a:xfrm>
-            <a:off x="822960" y="4892040"/>
-            <a:ext cx="3931920" cy="365760"/>
-          </a:xfrm>
-          <a:prstGeom prst="rect">
-            <a:avLst/>
-          </a:prstGeom>
-          <a:noFill/>
-        </p:spPr>
-        <p:txBody>
-          <a:bodyPr wrap="none">
-            <a:spAutoFit/>
-          </a:bodyPr>
-          <a:lstStyle/>
-          <a:p>
-            <a:pPr algn="ctr"/>
-            <a:r>
-              <a:rPr sz="1200" b="0">
-                <a:solidFill>
-                  <a:srgbClr val="595959"/>
-                </a:solidFill>
-                <a:latin typeface="Tahoma"/>
-              </a:rPr>
-              <a:t>ภาพตัวอย่างจริงที่ใช้ทดสอบ endpoint /predict</a:t>
-            </a:r>
-          </a:p>
-        </p:txBody>
-      </p:sp>
-      <p:sp>
-        <p:nvSpPr>
-          <p:cNvPr id="6" name="Rounded Rectangle 5"/>
-          <p:cNvSpPr/>
-          <p:nvPr/>
-        </p:nvSpPr>
-        <p:spPr>
-          <a:xfrm>
-            <a:off x="5166360" y="1417320"/>
-            <a:ext cx="6035040" cy="1097280"/>
-          </a:xfrm>
-          <a:prstGeom prst="roundRect">
-            <a:avLst/>
-          </a:prstGeom>
-          <a:solidFill>
-            <a:srgbClr val="DDEBF7"/>
-          </a:solidFill>
-          <a:ln>
-            <a:solidFill>
-              <a:srgbClr val="B4B4B4"/>
-            </a:solidFill>
-          </a:ln>
-        </p:spPr>
-        <p:style>
-          <a:lnRef idx="1">
-            <a:schemeClr val="accent1"/>
-          </a:lnRef>
-          <a:fillRef idx="3">
-            <a:schemeClr val="accent1"/>
-          </a:fillRef>
-          <a:effectRef idx="2">
-            <a:schemeClr val="accent1"/>
-          </a:effectRef>
-          <a:fontRef idx="minor">
-            <a:schemeClr val="lt1"/>
-          </a:fontRef>
-        </p:style>
-        <p:txBody>
-          <a:bodyPr rtlCol="0" anchor="ctr"/>
-          <a:lstStyle/>
-          <a:p>
-            <a:pPr algn="ctr"/>
-          </a:p>
-        </p:txBody>
-      </p:sp>
-      <p:sp>
-        <p:nvSpPr>
-          <p:cNvPr id="7" name="TextBox 6"/>
-          <p:cNvSpPr txBox="1"/>
-          <p:nvPr/>
-        </p:nvSpPr>
-        <p:spPr>
-          <a:xfrm>
-            <a:off x="5312664" y="1527048"/>
-            <a:ext cx="5742431" cy="914400"/>
-          </a:xfrm>
-          <a:prstGeom prst="rect">
-            <a:avLst/>
-          </a:prstGeom>
-          <a:noFill/>
-        </p:spPr>
-        <p:txBody>
-          <a:bodyPr wrap="none">
-            <a:spAutoFit/>
-          </a:bodyPr>
-          <a:lstStyle/>
-          <a:p>
-            <a:r>
-              <a:rPr sz="1700" b="1">
-                <a:solidFill>
-                  <a:srgbClr val="16365C"/>
-                </a:solidFill>
-                <a:latin typeface="Tahoma"/>
-              </a:rPr>
-              <a:t>ขั้นตอน Demo</a:t>
-            </a:r>
-          </a:p>
-          <a:p>
-            <a:pPr>
-              <a:spcBef>
-                <a:spcPts val="500"/>
-              </a:spcBef>
-              <a:defRPr sz="1500">
-                <a:solidFill>
-                  <a:srgbClr val="282828"/>
-                </a:solidFill>
-                <a:latin typeface="Tahoma"/>
-              </a:defRPr>
-            </a:pPr>
-            <a:r>
-              <a:t>เปิด Docker API → ส่งรูปภาพ → ตรวจ JSON response</a:t>
-            </a:r>
-          </a:p>
-        </p:txBody>
-      </p:sp>
-      <p:sp>
-        <p:nvSpPr>
-          <p:cNvPr id="8" name="Rounded Rectangle 7"/>
-          <p:cNvSpPr/>
-          <p:nvPr/>
-        </p:nvSpPr>
-        <p:spPr>
-          <a:xfrm>
-            <a:off x="5166360" y="2880360"/>
-            <a:ext cx="6035040" cy="1097280"/>
-          </a:xfrm>
-          <a:prstGeom prst="roundRect">
-            <a:avLst/>
-          </a:prstGeom>
-          <a:solidFill>
-            <a:srgbClr val="70AD47"/>
-          </a:solidFill>
-          <a:ln>
-            <a:solidFill>
-              <a:srgbClr val="B4B4B4"/>
-            </a:solidFill>
-          </a:ln>
-        </p:spPr>
-        <p:style>
-          <a:lnRef idx="1">
-            <a:schemeClr val="accent1"/>
-          </a:lnRef>
-          <a:fillRef idx="3">
-            <a:schemeClr val="accent1"/>
-          </a:fillRef>
-          <a:effectRef idx="2">
-            <a:schemeClr val="accent1"/>
-          </a:effectRef>
-          <a:fontRef idx="minor">
-            <a:schemeClr val="lt1"/>
-          </a:fontRef>
-        </p:style>
-        <p:txBody>
-          <a:bodyPr rtlCol="0" anchor="ctr"/>
-          <a:lstStyle/>
-          <a:p>
-            <a:pPr algn="ctr"/>
-          </a:p>
-        </p:txBody>
-      </p:sp>
-      <p:sp>
-        <p:nvSpPr>
-          <p:cNvPr id="9" name="TextBox 8"/>
-          <p:cNvSpPr txBox="1"/>
-          <p:nvPr/>
-        </p:nvSpPr>
-        <p:spPr>
-          <a:xfrm>
-            <a:off x="5312664" y="2990088"/>
-            <a:ext cx="5742431" cy="914400"/>
-          </a:xfrm>
-          <a:prstGeom prst="rect">
-            <a:avLst/>
-          </a:prstGeom>
-          <a:noFill/>
-        </p:spPr>
-        <p:txBody>
-          <a:bodyPr wrap="none">
-            <a:spAutoFit/>
-          </a:bodyPr>
-          <a:lstStyle/>
-          <a:p>
-            <a:r>
-              <a:rPr sz="1700" b="1">
-                <a:solidFill>
-                  <a:srgbClr val="16365C"/>
-                </a:solidFill>
-                <a:latin typeface="Tahoma"/>
-              </a:rPr>
-              <a:t>ผลลัพธ์ที่ได้</a:t>
-            </a:r>
-          </a:p>
-          <a:p>
-            <a:pPr>
-              <a:spcBef>
-                <a:spcPts val="500"/>
-              </a:spcBef>
-              <a:defRPr sz="1400">
-                <a:solidFill>
-                  <a:srgbClr val="282828"/>
-                </a:solidFill>
-                <a:latin typeface="Tahoma"/>
-              </a:defRPr>
-            </a:pPr>
-            <a:r>
-              <a:t>model: apple/mobilevit-small | runtime: onnx-quantized</a:t>
-            </a:r>
-          </a:p>
-        </p:txBody>
-      </p:sp>
-      <p:sp>
-        <p:nvSpPr>
-          <p:cNvPr id="10" name="Rounded Rectangle 9"/>
-          <p:cNvSpPr/>
-          <p:nvPr/>
-        </p:nvSpPr>
-        <p:spPr>
-          <a:xfrm>
-            <a:off x="5166360" y="4343400"/>
-            <a:ext cx="6035040" cy="1097280"/>
-          </a:xfrm>
-          <a:prstGeom prst="roundRect">
-            <a:avLst/>
-          </a:prstGeom>
-          <a:solidFill>
-            <a:srgbClr val="ED7D31"/>
-          </a:solidFill>
-          <a:ln>
-            <a:solidFill>
-              <a:srgbClr val="B4B4B4"/>
-            </a:solidFill>
-          </a:ln>
-        </p:spPr>
-        <p:style>
-          <a:lnRef idx="1">
-            <a:schemeClr val="accent1"/>
-          </a:lnRef>
-          <a:fillRef idx="3">
-            <a:schemeClr val="accent1"/>
-          </a:fillRef>
-          <a:effectRef idx="2">
-            <a:schemeClr val="accent1"/>
-          </a:effectRef>
-          <a:fontRef idx="minor">
-            <a:schemeClr val="lt1"/>
-          </a:fontRef>
-        </p:style>
-        <p:txBody>
-          <a:bodyPr rtlCol="0" anchor="ctr"/>
-          <a:lstStyle/>
-          <a:p>
-            <a:pPr algn="ctr"/>
-          </a:p>
-        </p:txBody>
-      </p:sp>
-      <p:sp>
-        <p:nvSpPr>
-          <p:cNvPr id="11" name="TextBox 10"/>
-          <p:cNvSpPr txBox="1"/>
-          <p:nvPr/>
-        </p:nvSpPr>
-        <p:spPr>
-          <a:xfrm>
-            <a:off x="5312664" y="4453128"/>
-            <a:ext cx="5742431" cy="914400"/>
-          </a:xfrm>
-          <a:prstGeom prst="rect">
-            <a:avLst/>
-          </a:prstGeom>
-          <a:noFill/>
-        </p:spPr>
-        <p:txBody>
-          <a:bodyPr wrap="none">
-            <a:spAutoFit/>
-          </a:bodyPr>
-          <a:lstStyle/>
-          <a:p>
-            <a:r>
-              <a:rPr sz="1700" b="1">
-                <a:solidFill>
-                  <a:srgbClr val="16365C"/>
-                </a:solidFill>
-                <a:latin typeface="Tahoma"/>
-              </a:rPr>
-              <a:t>Top Predictions</a:t>
-            </a:r>
-          </a:p>
-          <a:p>
-            <a:pPr>
-              <a:spcBef>
-                <a:spcPts val="500"/>
-              </a:spcBef>
-              <a:defRPr sz="1400">
-                <a:solidFill>
-                  <a:srgbClr val="282828"/>
-                </a:solidFill>
-                <a:latin typeface="Tahoma"/>
-              </a:defRPr>
-            </a:pPr>
-            <a:r>
-              <a:t>tabby cat, Egyptian cat, tiger cat</a:t>
-            </a:r>
-          </a:p>
-        </p:txBody>
-      </p:sp>
-      <p:sp>
-        <p:nvSpPr>
-          <p:cNvPr id="12" name="TextBox 11"/>
-          <p:cNvSpPr txBox="1"/>
-          <p:nvPr/>
-        </p:nvSpPr>
-        <p:spPr>
-          <a:xfrm>
-            <a:off x="9646920" y="6446520"/>
-            <a:ext cx="1920240" cy="228600"/>
-          </a:xfrm>
-          <a:prstGeom prst="rect">
-            <a:avLst/>
-          </a:prstGeom>
-          <a:noFill/>
-        </p:spPr>
-        <p:txBody>
-          <a:bodyPr wrap="none">
-            <a:spAutoFit/>
-          </a:bodyPr>
-          <a:lstStyle/>
-          <a:p>
-            <a:pPr algn="r"/>
-            <a:r>
-              <a:rPr sz="900" b="0">
-                <a:solidFill>
-                  <a:srgbClr val="595959"/>
-                </a:solidFill>
-                <a:latin typeface="Tahoma"/>
-              </a:rPr>
-              <a:t>MobileViT MLOps | 12</a:t>
-            </a:r>
-          </a:p>
-        </p:txBody>
-      </p:sp>
-    </p:spTree>
-  </p:cSld>
-  <p:clrMapOvr>
-    <a:masterClrMapping/>
-  </p:clrMapOvr>
-</p:sld>
-</file>
-
-<file path=ppt/slides/slide13.xml><?xml version="1.0" encoding="utf-8"?>
-<p:sld xmlns:a="http://schemas.openxmlformats.org/drawingml/2006/main" xmlns:p="http://schemas.openxmlformats.org/presentationml/2006/main" xmlns:r="http://schemas.openxmlformats.org/officeDocument/2006/relationships">
-  <p:cSld>
-    <p:spTree>
-      <p:nvGrpSpPr>
-        <p:cNvPr id="1" name=""/>
-        <p:cNvGrpSpPr/>
-        <p:nvPr/>
-      </p:nvGrpSpPr>
-      <p:grpSpPr/>
-      <p:sp>
-        <p:nvSpPr>
-          <p:cNvPr id="2" name="TextBox 1"/>
-          <p:cNvSpPr txBox="1"/>
-          <p:nvPr/>
-        </p:nvSpPr>
-        <p:spPr>
-          <a:xfrm>
-            <a:off x="594360" y="320040"/>
-            <a:ext cx="10972800" cy="640080"/>
-          </a:xfrm>
-          <a:prstGeom prst="rect">
-            <a:avLst/>
-          </a:prstGeom>
-          <a:noFill/>
-        </p:spPr>
-        <p:txBody>
-          <a:bodyPr wrap="none">
-            <a:spAutoFit/>
-          </a:bodyPr>
-          <a:lstStyle/>
-          <a:p>
-            <a:pPr algn="l"/>
-            <a:r>
-              <a:rPr sz="2800" b="1">
-                <a:solidFill>
-                  <a:srgbClr val="16365C"/>
-                </a:solidFill>
-                <a:latin typeface="Tahoma"/>
-              </a:rPr>
-              <a:t>Deliverables ที่จัดทำ</a:t>
-            </a:r>
-          </a:p>
-        </p:txBody>
-      </p:sp>
-      <p:sp>
-        <p:nvSpPr>
-          <p:cNvPr id="3" name="Rectangle 2"/>
-          <p:cNvSpPr/>
-          <p:nvPr/>
-        </p:nvSpPr>
-        <p:spPr>
-          <a:xfrm>
-            <a:off x="594360" y="1024128"/>
-            <a:ext cx="10972800" cy="36576"/>
-          </a:xfrm>
-          <a:prstGeom prst="rect">
-            <a:avLst/>
-          </a:prstGeom>
-          <a:solidFill>
-            <a:srgbClr val="3275B5"/>
-          </a:solidFill>
-          <a:ln>
-            <a:noFill/>
-          </a:ln>
-        </p:spPr>
-        <p:style>
-          <a:lnRef idx="1">
-            <a:schemeClr val="accent1"/>
-          </a:lnRef>
-          <a:fillRef idx="3">
-            <a:schemeClr val="accent1"/>
-          </a:fillRef>
-          <a:effectRef idx="2">
-            <a:schemeClr val="accent1"/>
-          </a:effectRef>
-          <a:fontRef idx="minor">
-            <a:schemeClr val="lt1"/>
-          </a:fontRef>
-        </p:style>
-        <p:txBody>
-          <a:bodyPr rtlCol="0" anchor="ctr"/>
-          <a:lstStyle/>
-          <a:p>
-            <a:pPr algn="ctr"/>
-          </a:p>
-        </p:txBody>
-      </p:sp>
-      <p:sp>
-        <p:nvSpPr>
-          <p:cNvPr id="4" name="TextBox 3"/>
-          <p:cNvSpPr txBox="1"/>
-          <p:nvPr/>
-        </p:nvSpPr>
-        <p:spPr>
-          <a:xfrm>
-            <a:off x="777240" y="1417320"/>
-            <a:ext cx="10789920" cy="4297680"/>
-          </a:xfrm>
-          <a:prstGeom prst="rect">
-            <a:avLst/>
-          </a:prstGeom>
-          <a:noFill/>
-        </p:spPr>
-        <p:txBody>
-          <a:bodyPr wrap="none">
-            <a:spAutoFit/>
-          </a:bodyPr>
-          <a:lstStyle/>
-          <a:p>
-            <a:pPr>
-              <a:spcAft>
-                <a:spcPts val="800"/>
-              </a:spcAft>
-              <a:defRPr sz="2000">
-                <a:solidFill>
-                  <a:srgbClr val="282828"/>
-                </a:solidFill>
-                <a:latin typeface="Tahoma"/>
-              </a:defRPr>
-            </a:pPr>
-            <a:r>
-              <a:t>Source Code Repository บน GitHub</a:t>
-            </a:r>
-          </a:p>
-          <a:p>
-            <a:pPr>
-              <a:spcAft>
-                <a:spcPts val="800"/>
-              </a:spcAft>
-              <a:defRPr sz="2000">
-                <a:solidFill>
-                  <a:srgbClr val="282828"/>
-                </a:solidFill>
-                <a:latin typeface="Tahoma"/>
-              </a:defRPr>
-            </a:pPr>
-            <a:r>
-              <a:t>README.md ภาษาไทย พร้อมวิธีใช้งานและ cURL</a:t>
-            </a:r>
-          </a:p>
-          <a:p>
-            <a:pPr>
-              <a:spcAft>
-                <a:spcPts val="800"/>
-              </a:spcAft>
-              <a:defRPr sz="2000">
-                <a:solidFill>
-                  <a:srgbClr val="282828"/>
-                </a:solidFill>
-                <a:latin typeface="Tahoma"/>
-              </a:defRPr>
-            </a:pPr>
-            <a:r>
-              <a:t>Dockerfile และโมเดล ONNX Quantized</a:t>
-            </a:r>
-          </a:p>
-          <a:p>
-            <a:pPr>
-              <a:spcAft>
-                <a:spcPts val="800"/>
-              </a:spcAft>
-              <a:defRPr sz="2000">
-                <a:solidFill>
-                  <a:srgbClr val="282828"/>
-                </a:solidFill>
-                <a:latin typeface="Tahoma"/>
-              </a:defRPr>
-            </a:pPr>
-            <a:r>
-              <a:t>GitHub Actions สำหรับ CI/CD</a:t>
-            </a:r>
-          </a:p>
-          <a:p>
-            <a:pPr>
-              <a:spcAft>
-                <a:spcPts val="800"/>
-              </a:spcAft>
-              <a:defRPr sz="2000">
-                <a:solidFill>
-                  <a:srgbClr val="282828"/>
-                </a:solidFill>
-                <a:latin typeface="Tahoma"/>
-              </a:defRPr>
-            </a:pPr>
-            <a:r>
-              <a:t>Postman Collection และ JMeter Test Plan</a:t>
-            </a:r>
-          </a:p>
-          <a:p>
-            <a:pPr>
-              <a:spcAft>
-                <a:spcPts val="800"/>
-              </a:spcAft>
-              <a:defRPr sz="2000">
-                <a:solidFill>
-                  <a:srgbClr val="282828"/>
-                </a:solidFill>
-                <a:latin typeface="Tahoma"/>
-              </a:defRPr>
-            </a:pPr>
-            <a:r>
-              <a:t>รายงาน PDF และสไลด์นำเสนอ</a:t>
-            </a:r>
-          </a:p>
-        </p:txBody>
-      </p:sp>
-      <p:sp>
-        <p:nvSpPr>
-          <p:cNvPr id="5" name="TextBox 4"/>
-          <p:cNvSpPr txBox="1"/>
-          <p:nvPr/>
-        </p:nvSpPr>
-        <p:spPr>
-          <a:xfrm>
-            <a:off x="9646920" y="6446520"/>
-            <a:ext cx="1920240" cy="228600"/>
-          </a:xfrm>
-          <a:prstGeom prst="rect">
-            <a:avLst/>
-          </a:prstGeom>
-          <a:noFill/>
-        </p:spPr>
-        <p:txBody>
-          <a:bodyPr wrap="none">
-            <a:spAutoFit/>
-          </a:bodyPr>
-          <a:lstStyle/>
-          <a:p>
-            <a:pPr algn="r"/>
-            <a:r>
-              <a:rPr sz="900" b="0">
-                <a:solidFill>
-                  <a:srgbClr val="595959"/>
-                </a:solidFill>
-                <a:latin typeface="Tahoma"/>
-              </a:rPr>
               <a:t>MobileViT MLOps | 13</a:t>
             </a:r>
           </a:p>
@@ -5328,7 +4933,7 @@
                 </a:solidFill>
                 <a:latin typeface="Tahoma"/>
               </a:rPr>
-              <a:t>สรุปผล</a:t>
+              <a:t>CI/CD Pipeline</a:t>
             </a:r>
           </a:p>
         </p:txBody>
@@ -5378,6 +4983,1442 @@
       </p:sp>
       <p:sp>
         <p:nvSpPr>
+          <p:cNvPr id="4" name="Rounded Rectangle 3"/>
+          <p:cNvSpPr/>
+          <p:nvPr/>
+        </p:nvSpPr>
+        <p:spPr>
+          <a:xfrm>
+            <a:off x="914400" y="1691640"/>
+            <a:ext cx="2057400" cy="1097280"/>
+          </a:xfrm>
+          <a:prstGeom prst="roundRect">
+            <a:avLst/>
+          </a:prstGeom>
+          <a:solidFill>
+            <a:srgbClr val="E8F2FA"/>
+          </a:solidFill>
+          <a:ln>
+            <a:solidFill>
+              <a:srgbClr val="B4B4B4"/>
+            </a:solidFill>
+          </a:ln>
+        </p:spPr>
+        <p:style>
+          <a:lnRef idx="1">
+            <a:schemeClr val="accent1"/>
+          </a:lnRef>
+          <a:fillRef idx="3">
+            <a:schemeClr val="accent1"/>
+          </a:fillRef>
+          <a:effectRef idx="2">
+            <a:schemeClr val="accent1"/>
+          </a:effectRef>
+          <a:fontRef idx="minor">
+            <a:schemeClr val="lt1"/>
+          </a:fontRef>
+        </p:style>
+        <p:txBody>
+          <a:bodyPr rtlCol="0" anchor="ctr"/>
+          <a:lstStyle/>
+          <a:p>
+            <a:pPr algn="ctr"/>
+          </a:p>
+        </p:txBody>
+      </p:sp>
+      <p:sp>
+        <p:nvSpPr>
+          <p:cNvPr id="5" name="TextBox 4"/>
+          <p:cNvSpPr txBox="1"/>
+          <p:nvPr/>
+        </p:nvSpPr>
+        <p:spPr>
+          <a:xfrm>
+            <a:off x="1060704" y="1801368"/>
+            <a:ext cx="1764792" cy="914400"/>
+          </a:xfrm>
+          <a:prstGeom prst="rect">
+            <a:avLst/>
+          </a:prstGeom>
+          <a:noFill/>
+        </p:spPr>
+        <p:txBody>
+          <a:bodyPr wrap="none">
+            <a:spAutoFit/>
+          </a:bodyPr>
+          <a:lstStyle/>
+          <a:p>
+            <a:r>
+              <a:rPr sz="1600" b="1">
+                <a:solidFill>
+                  <a:srgbClr val="16365C"/>
+                </a:solidFill>
+                <a:latin typeface="Tahoma"/>
+              </a:rPr>
+              <a:t>Push Code</a:t>
+            </a:r>
+          </a:p>
+          <a:p>
+            <a:pPr>
+              <a:spcBef>
+                <a:spcPts val="500"/>
+              </a:spcBef>
+              <a:defRPr sz="1300">
+                <a:solidFill>
+                  <a:srgbClr val="282828"/>
+                </a:solidFill>
+                <a:latin typeface="Tahoma"/>
+              </a:defRPr>
+            </a:pPr>
+            <a:r>
+              <a:t>GitHub</a:t>
+            </a:r>
+          </a:p>
+        </p:txBody>
+      </p:sp>
+      <p:sp>
+        <p:nvSpPr>
+          <p:cNvPr id="6" name="Right Arrow 5"/>
+          <p:cNvSpPr/>
+          <p:nvPr/>
+        </p:nvSpPr>
+        <p:spPr>
+          <a:xfrm>
+            <a:off x="3035808" y="2148840"/>
+            <a:ext cx="411480" cy="210312"/>
+          </a:xfrm>
+          <a:prstGeom prst="rightArrow">
+            <a:avLst/>
+          </a:prstGeom>
+          <a:solidFill>
+            <a:srgbClr val="3275B5"/>
+          </a:solidFill>
+          <a:ln>
+            <a:noFill/>
+          </a:ln>
+        </p:spPr>
+        <p:style>
+          <a:lnRef idx="1">
+            <a:schemeClr val="accent1"/>
+          </a:lnRef>
+          <a:fillRef idx="3">
+            <a:schemeClr val="accent1"/>
+          </a:fillRef>
+          <a:effectRef idx="2">
+            <a:schemeClr val="accent1"/>
+          </a:effectRef>
+          <a:fontRef idx="minor">
+            <a:schemeClr val="lt1"/>
+          </a:fontRef>
+        </p:style>
+        <p:txBody>
+          <a:bodyPr rtlCol="0" anchor="ctr"/>
+          <a:lstStyle/>
+          <a:p>
+            <a:pPr algn="ctr"/>
+          </a:p>
+        </p:txBody>
+      </p:sp>
+      <p:sp>
+        <p:nvSpPr>
+          <p:cNvPr id="7" name="Rounded Rectangle 6"/>
+          <p:cNvSpPr/>
+          <p:nvPr/>
+        </p:nvSpPr>
+        <p:spPr>
+          <a:xfrm>
+            <a:off x="3474720" y="1691640"/>
+            <a:ext cx="2057400" cy="1097280"/>
+          </a:xfrm>
+          <a:prstGeom prst="roundRect">
+            <a:avLst/>
+          </a:prstGeom>
+          <a:solidFill>
+            <a:srgbClr val="E8F2FA"/>
+          </a:solidFill>
+          <a:ln>
+            <a:solidFill>
+              <a:srgbClr val="B4B4B4"/>
+            </a:solidFill>
+          </a:ln>
+        </p:spPr>
+        <p:style>
+          <a:lnRef idx="1">
+            <a:schemeClr val="accent1"/>
+          </a:lnRef>
+          <a:fillRef idx="3">
+            <a:schemeClr val="accent1"/>
+          </a:fillRef>
+          <a:effectRef idx="2">
+            <a:schemeClr val="accent1"/>
+          </a:effectRef>
+          <a:fontRef idx="minor">
+            <a:schemeClr val="lt1"/>
+          </a:fontRef>
+        </p:style>
+        <p:txBody>
+          <a:bodyPr rtlCol="0" anchor="ctr"/>
+          <a:lstStyle/>
+          <a:p>
+            <a:pPr algn="ctr"/>
+          </a:p>
+        </p:txBody>
+      </p:sp>
+      <p:sp>
+        <p:nvSpPr>
+          <p:cNvPr id="8" name="TextBox 7"/>
+          <p:cNvSpPr txBox="1"/>
+          <p:nvPr/>
+        </p:nvSpPr>
+        <p:spPr>
+          <a:xfrm>
+            <a:off x="3621024" y="1801368"/>
+            <a:ext cx="1764792" cy="914400"/>
+          </a:xfrm>
+          <a:prstGeom prst="rect">
+            <a:avLst/>
+          </a:prstGeom>
+          <a:noFill/>
+        </p:spPr>
+        <p:txBody>
+          <a:bodyPr wrap="none">
+            <a:spAutoFit/>
+          </a:bodyPr>
+          <a:lstStyle/>
+          <a:p>
+            <a:r>
+              <a:rPr sz="1600" b="1">
+                <a:solidFill>
+                  <a:srgbClr val="16365C"/>
+                </a:solidFill>
+                <a:latin typeface="Tahoma"/>
+              </a:rPr>
+              <a:t>Install</a:t>
+            </a:r>
+          </a:p>
+          <a:p>
+            <a:pPr>
+              <a:spcBef>
+                <a:spcPts val="500"/>
+              </a:spcBef>
+              <a:defRPr sz="1300">
+                <a:solidFill>
+                  <a:srgbClr val="282828"/>
+                </a:solidFill>
+                <a:latin typeface="Tahoma"/>
+              </a:defRPr>
+            </a:pPr>
+            <a:r>
+              <a:t>Dependencies</a:t>
+            </a:r>
+          </a:p>
+        </p:txBody>
+      </p:sp>
+      <p:sp>
+        <p:nvSpPr>
+          <p:cNvPr id="9" name="Right Arrow 8"/>
+          <p:cNvSpPr/>
+          <p:nvPr/>
+        </p:nvSpPr>
+        <p:spPr>
+          <a:xfrm>
+            <a:off x="5596127" y="2148840"/>
+            <a:ext cx="411480" cy="210312"/>
+          </a:xfrm>
+          <a:prstGeom prst="rightArrow">
+            <a:avLst/>
+          </a:prstGeom>
+          <a:solidFill>
+            <a:srgbClr val="3275B5"/>
+          </a:solidFill>
+          <a:ln>
+            <a:noFill/>
+          </a:ln>
+        </p:spPr>
+        <p:style>
+          <a:lnRef idx="1">
+            <a:schemeClr val="accent1"/>
+          </a:lnRef>
+          <a:fillRef idx="3">
+            <a:schemeClr val="accent1"/>
+          </a:fillRef>
+          <a:effectRef idx="2">
+            <a:schemeClr val="accent1"/>
+          </a:effectRef>
+          <a:fontRef idx="minor">
+            <a:schemeClr val="lt1"/>
+          </a:fontRef>
+        </p:style>
+        <p:txBody>
+          <a:bodyPr rtlCol="0" anchor="ctr"/>
+          <a:lstStyle/>
+          <a:p>
+            <a:pPr algn="ctr"/>
+          </a:p>
+        </p:txBody>
+      </p:sp>
+      <p:sp>
+        <p:nvSpPr>
+          <p:cNvPr id="10" name="Rounded Rectangle 9"/>
+          <p:cNvSpPr/>
+          <p:nvPr/>
+        </p:nvSpPr>
+        <p:spPr>
+          <a:xfrm>
+            <a:off x="6035040" y="1691640"/>
+            <a:ext cx="2057400" cy="1097280"/>
+          </a:xfrm>
+          <a:prstGeom prst="roundRect">
+            <a:avLst/>
+          </a:prstGeom>
+          <a:solidFill>
+            <a:srgbClr val="E8F2FA"/>
+          </a:solidFill>
+          <a:ln>
+            <a:solidFill>
+              <a:srgbClr val="B4B4B4"/>
+            </a:solidFill>
+          </a:ln>
+        </p:spPr>
+        <p:style>
+          <a:lnRef idx="1">
+            <a:schemeClr val="accent1"/>
+          </a:lnRef>
+          <a:fillRef idx="3">
+            <a:schemeClr val="accent1"/>
+          </a:fillRef>
+          <a:effectRef idx="2">
+            <a:schemeClr val="accent1"/>
+          </a:effectRef>
+          <a:fontRef idx="minor">
+            <a:schemeClr val="lt1"/>
+          </a:fontRef>
+        </p:style>
+        <p:txBody>
+          <a:bodyPr rtlCol="0" anchor="ctr"/>
+          <a:lstStyle/>
+          <a:p>
+            <a:pPr algn="ctr"/>
+          </a:p>
+        </p:txBody>
+      </p:sp>
+      <p:sp>
+        <p:nvSpPr>
+          <p:cNvPr id="11" name="TextBox 10"/>
+          <p:cNvSpPr txBox="1"/>
+          <p:nvPr/>
+        </p:nvSpPr>
+        <p:spPr>
+          <a:xfrm>
+            <a:off x="6181344" y="1801368"/>
+            <a:ext cx="1764792" cy="914400"/>
+          </a:xfrm>
+          <a:prstGeom prst="rect">
+            <a:avLst/>
+          </a:prstGeom>
+          <a:noFill/>
+        </p:spPr>
+        <p:txBody>
+          <a:bodyPr wrap="none">
+            <a:spAutoFit/>
+          </a:bodyPr>
+          <a:lstStyle/>
+          <a:p>
+            <a:r>
+              <a:rPr sz="1600" b="1">
+                <a:solidFill>
+                  <a:srgbClr val="16365C"/>
+                </a:solidFill>
+                <a:latin typeface="Tahoma"/>
+              </a:rPr>
+              <a:t>Test</a:t>
+            </a:r>
+          </a:p>
+          <a:p>
+            <a:pPr>
+              <a:spcBef>
+                <a:spcPts val="500"/>
+              </a:spcBef>
+              <a:defRPr sz="1300">
+                <a:solidFill>
+                  <a:srgbClr val="282828"/>
+                </a:solidFill>
+                <a:latin typeface="Tahoma"/>
+              </a:defRPr>
+            </a:pPr>
+            <a:r>
+              <a:t>pytest</a:t>
+            </a:r>
+          </a:p>
+        </p:txBody>
+      </p:sp>
+      <p:sp>
+        <p:nvSpPr>
+          <p:cNvPr id="12" name="Right Arrow 11"/>
+          <p:cNvSpPr/>
+          <p:nvPr/>
+        </p:nvSpPr>
+        <p:spPr>
+          <a:xfrm>
+            <a:off x="8156448" y="2148840"/>
+            <a:ext cx="411480" cy="210312"/>
+          </a:xfrm>
+          <a:prstGeom prst="rightArrow">
+            <a:avLst/>
+          </a:prstGeom>
+          <a:solidFill>
+            <a:srgbClr val="3275B5"/>
+          </a:solidFill>
+          <a:ln>
+            <a:noFill/>
+          </a:ln>
+        </p:spPr>
+        <p:style>
+          <a:lnRef idx="1">
+            <a:schemeClr val="accent1"/>
+          </a:lnRef>
+          <a:fillRef idx="3">
+            <a:schemeClr val="accent1"/>
+          </a:fillRef>
+          <a:effectRef idx="2">
+            <a:schemeClr val="accent1"/>
+          </a:effectRef>
+          <a:fontRef idx="minor">
+            <a:schemeClr val="lt1"/>
+          </a:fontRef>
+        </p:style>
+        <p:txBody>
+          <a:bodyPr rtlCol="0" anchor="ctr"/>
+          <a:lstStyle/>
+          <a:p>
+            <a:pPr algn="ctr"/>
+          </a:p>
+        </p:txBody>
+      </p:sp>
+      <p:sp>
+        <p:nvSpPr>
+          <p:cNvPr id="13" name="Rounded Rectangle 12"/>
+          <p:cNvSpPr/>
+          <p:nvPr/>
+        </p:nvSpPr>
+        <p:spPr>
+          <a:xfrm>
+            <a:off x="8595359" y="1691640"/>
+            <a:ext cx="2057400" cy="1097280"/>
+          </a:xfrm>
+          <a:prstGeom prst="roundRect">
+            <a:avLst/>
+          </a:prstGeom>
+          <a:solidFill>
+            <a:srgbClr val="E8F2FA"/>
+          </a:solidFill>
+          <a:ln>
+            <a:solidFill>
+              <a:srgbClr val="B4B4B4"/>
+            </a:solidFill>
+          </a:ln>
+        </p:spPr>
+        <p:style>
+          <a:lnRef idx="1">
+            <a:schemeClr val="accent1"/>
+          </a:lnRef>
+          <a:fillRef idx="3">
+            <a:schemeClr val="accent1"/>
+          </a:fillRef>
+          <a:effectRef idx="2">
+            <a:schemeClr val="accent1"/>
+          </a:effectRef>
+          <a:fontRef idx="minor">
+            <a:schemeClr val="lt1"/>
+          </a:fontRef>
+        </p:style>
+        <p:txBody>
+          <a:bodyPr rtlCol="0" anchor="ctr"/>
+          <a:lstStyle/>
+          <a:p>
+            <a:pPr algn="ctr"/>
+          </a:p>
+        </p:txBody>
+      </p:sp>
+      <p:sp>
+        <p:nvSpPr>
+          <p:cNvPr id="14" name="TextBox 13"/>
+          <p:cNvSpPr txBox="1"/>
+          <p:nvPr/>
+        </p:nvSpPr>
+        <p:spPr>
+          <a:xfrm>
+            <a:off x="8741663" y="1801368"/>
+            <a:ext cx="1764792" cy="914400"/>
+          </a:xfrm>
+          <a:prstGeom prst="rect">
+            <a:avLst/>
+          </a:prstGeom>
+          <a:noFill/>
+        </p:spPr>
+        <p:txBody>
+          <a:bodyPr wrap="none">
+            <a:spAutoFit/>
+          </a:bodyPr>
+          <a:lstStyle/>
+          <a:p>
+            <a:r>
+              <a:rPr sz="1600" b="1">
+                <a:solidFill>
+                  <a:srgbClr val="16365C"/>
+                </a:solidFill>
+                <a:latin typeface="Tahoma"/>
+              </a:rPr>
+              <a:t>Deploy</a:t>
+            </a:r>
+          </a:p>
+          <a:p>
+            <a:pPr>
+              <a:spcBef>
+                <a:spcPts val="500"/>
+              </a:spcBef>
+              <a:defRPr sz="1300">
+                <a:solidFill>
+                  <a:srgbClr val="282828"/>
+                </a:solidFill>
+                <a:latin typeface="Tahoma"/>
+              </a:defRPr>
+            </a:pPr>
+            <a:r>
+              <a:t>Hugging Face Spaces</a:t>
+            </a:r>
+          </a:p>
+        </p:txBody>
+      </p:sp>
+      <p:sp>
+        <p:nvSpPr>
+          <p:cNvPr id="15" name="TextBox 14"/>
+          <p:cNvSpPr txBox="1"/>
+          <p:nvPr/>
+        </p:nvSpPr>
+        <p:spPr>
+          <a:xfrm>
+            <a:off x="777240" y="3794760"/>
+            <a:ext cx="10789920" cy="4297680"/>
+          </a:xfrm>
+          <a:prstGeom prst="rect">
+            <a:avLst/>
+          </a:prstGeom>
+          <a:noFill/>
+        </p:spPr>
+        <p:txBody>
+          <a:bodyPr wrap="none">
+            <a:spAutoFit/>
+          </a:bodyPr>
+          <a:lstStyle/>
+          <a:p>
+            <a:pPr>
+              <a:spcAft>
+                <a:spcPts val="800"/>
+              </a:spcAft>
+              <a:defRPr sz="1800">
+                <a:solidFill>
+                  <a:srgbClr val="282828"/>
+                </a:solidFill>
+                <a:latin typeface="Tahoma"/>
+              </a:defRPr>
+            </a:pPr>
+            <a:r>
+              <a:t>Workflow อยู่ที่ .github/workflows/ci-cd.yml</a:t>
+            </a:r>
+          </a:p>
+          <a:p>
+            <a:pPr>
+              <a:spcAft>
+                <a:spcPts val="800"/>
+              </a:spcAft>
+              <a:defRPr sz="1800">
+                <a:solidFill>
+                  <a:srgbClr val="282828"/>
+                </a:solidFill>
+                <a:latin typeface="Tahoma"/>
+              </a:defRPr>
+            </a:pPr>
+            <a:r>
+              <a:t>รัน unit test ทุกครั้งที่ push หรือ pull request ไปยัง main</a:t>
+            </a:r>
+          </a:p>
+          <a:p>
+            <a:pPr>
+              <a:spcAft>
+                <a:spcPts val="800"/>
+              </a:spcAft>
+              <a:defRPr sz="1800">
+                <a:solidFill>
+                  <a:srgbClr val="282828"/>
+                </a:solidFill>
+                <a:latin typeface="Tahoma"/>
+              </a:defRPr>
+            </a:pPr>
+            <a:r>
+              <a:t>รองรับ auto-deploy เมื่อกำหนด HF_TOKEN และ HF_SPACE_REPO_ID</a:t>
+            </a:r>
+          </a:p>
+        </p:txBody>
+      </p:sp>
+      <p:sp>
+        <p:nvSpPr>
+          <p:cNvPr id="16" name="TextBox 15"/>
+          <p:cNvSpPr txBox="1"/>
+          <p:nvPr/>
+        </p:nvSpPr>
+        <p:spPr>
+          <a:xfrm>
+            <a:off x="9646920" y="6446520"/>
+            <a:ext cx="1920240" cy="228600"/>
+          </a:xfrm>
+          <a:prstGeom prst="rect">
+            <a:avLst/>
+          </a:prstGeom>
+          <a:noFill/>
+        </p:spPr>
+        <p:txBody>
+          <a:bodyPr wrap="none">
+            <a:spAutoFit/>
+          </a:bodyPr>
+          <a:lstStyle/>
+          <a:p>
+            <a:pPr algn="r"/>
+            <a:r>
+              <a:rPr sz="900" b="0">
+                <a:solidFill>
+                  <a:srgbClr val="595959"/>
+                </a:solidFill>
+                <a:latin typeface="Tahoma"/>
+              </a:rPr>
+              <a:t>MobileViT MLOps | 14</a:t>
+            </a:r>
+          </a:p>
+        </p:txBody>
+      </p:sp>
+    </p:spTree>
+  </p:cSld>
+  <p:clrMapOvr>
+    <a:masterClrMapping/>
+  </p:clrMapOvr>
+</p:sld>
+</file>
+
+<file path=ppt/slides/slide15.xml><?xml version="1.0" encoding="utf-8"?>
+<p:sld xmlns:a="http://schemas.openxmlformats.org/drawingml/2006/main" xmlns:p="http://schemas.openxmlformats.org/presentationml/2006/main" xmlns:r="http://schemas.openxmlformats.org/officeDocument/2006/relationships">
+  <p:cSld>
+    <p:spTree>
+      <p:nvGrpSpPr>
+        <p:cNvPr id="1" name=""/>
+        <p:cNvGrpSpPr/>
+        <p:nvPr/>
+      </p:nvGrpSpPr>
+      <p:grpSpPr/>
+      <p:sp>
+        <p:nvSpPr>
+          <p:cNvPr id="2" name="TextBox 1"/>
+          <p:cNvSpPr txBox="1"/>
+          <p:nvPr/>
+        </p:nvSpPr>
+        <p:spPr>
+          <a:xfrm>
+            <a:off x="594360" y="320040"/>
+            <a:ext cx="10972800" cy="640080"/>
+          </a:xfrm>
+          <a:prstGeom prst="rect">
+            <a:avLst/>
+          </a:prstGeom>
+          <a:noFill/>
+        </p:spPr>
+        <p:txBody>
+          <a:bodyPr wrap="none">
+            <a:spAutoFit/>
+          </a:bodyPr>
+          <a:lstStyle/>
+          <a:p>
+            <a:pPr algn="l"/>
+            <a:r>
+              <a:rPr sz="2800" b="1">
+                <a:solidFill>
+                  <a:srgbClr val="16365C"/>
+                </a:solidFill>
+                <a:latin typeface="Tahoma"/>
+              </a:rPr>
+              <a:t>Live Demo: API บน Docker</a:t>
+            </a:r>
+          </a:p>
+        </p:txBody>
+      </p:sp>
+      <p:sp>
+        <p:nvSpPr>
+          <p:cNvPr id="3" name="Rectangle 2"/>
+          <p:cNvSpPr/>
+          <p:nvPr/>
+        </p:nvSpPr>
+        <p:spPr>
+          <a:xfrm>
+            <a:off x="594360" y="1024128"/>
+            <a:ext cx="10972800" cy="36576"/>
+          </a:xfrm>
+          <a:prstGeom prst="rect">
+            <a:avLst/>
+          </a:prstGeom>
+          <a:solidFill>
+            <a:srgbClr val="3275B5"/>
+          </a:solidFill>
+          <a:ln>
+            <a:noFill/>
+          </a:ln>
+        </p:spPr>
+        <p:style>
+          <a:lnRef idx="1">
+            <a:schemeClr val="accent1"/>
+          </a:lnRef>
+          <a:fillRef idx="3">
+            <a:schemeClr val="accent1"/>
+          </a:fillRef>
+          <a:effectRef idx="2">
+            <a:schemeClr val="accent1"/>
+          </a:effectRef>
+          <a:fontRef idx="minor">
+            <a:schemeClr val="lt1"/>
+          </a:fontRef>
+        </p:style>
+        <p:txBody>
+          <a:bodyPr rtlCol="0" anchor="ctr"/>
+          <a:lstStyle/>
+          <a:p>
+            <a:pPr algn="ctr"/>
+          </a:p>
+        </p:txBody>
+      </p:sp>
+      <p:pic>
+        <p:nvPicPr>
+          <p:cNvPr id="4" name="Picture 3" descr="benchmark.png"/>
+          <p:cNvPicPr>
+            <a:picLocks noChangeAspect="1"/>
+          </p:cNvPicPr>
+          <p:nvPr/>
+        </p:nvPicPr>
+        <p:blipFill>
+          <a:blip r:embed="rId2"/>
+          <a:stretch>
+            <a:fillRect/>
+          </a:stretch>
+        </p:blipFill>
+        <p:spPr>
+          <a:xfrm>
+            <a:off x="822960" y="1417320"/>
+            <a:ext cx="3931920" cy="2604423"/>
+          </a:xfrm>
+          <a:prstGeom prst="rect">
+            <a:avLst/>
+          </a:prstGeom>
+        </p:spPr>
+      </p:pic>
+      <p:sp>
+        <p:nvSpPr>
+          <p:cNvPr id="5" name="TextBox 4"/>
+          <p:cNvSpPr txBox="1"/>
+          <p:nvPr/>
+        </p:nvSpPr>
+        <p:spPr>
+          <a:xfrm>
+            <a:off x="822960" y="4892040"/>
+            <a:ext cx="3931920" cy="365760"/>
+          </a:xfrm>
+          <a:prstGeom prst="rect">
+            <a:avLst/>
+          </a:prstGeom>
+          <a:noFill/>
+        </p:spPr>
+        <p:txBody>
+          <a:bodyPr wrap="none">
+            <a:spAutoFit/>
+          </a:bodyPr>
+          <a:lstStyle/>
+          <a:p>
+            <a:pPr algn="ctr"/>
+            <a:r>
+              <a:rPr sz="1200" b="0">
+                <a:solidFill>
+                  <a:srgbClr val="595959"/>
+                </a:solidFill>
+                <a:latin typeface="Tahoma"/>
+              </a:rPr>
+              <a:t>ภาพตัวอย่างจริงที่ใช้ทดสอบ endpoint /predict</a:t>
+            </a:r>
+          </a:p>
+        </p:txBody>
+      </p:sp>
+      <p:sp>
+        <p:nvSpPr>
+          <p:cNvPr id="6" name="Rounded Rectangle 5"/>
+          <p:cNvSpPr/>
+          <p:nvPr/>
+        </p:nvSpPr>
+        <p:spPr>
+          <a:xfrm>
+            <a:off x="5166360" y="1417320"/>
+            <a:ext cx="6035040" cy="1097280"/>
+          </a:xfrm>
+          <a:prstGeom prst="roundRect">
+            <a:avLst/>
+          </a:prstGeom>
+          <a:solidFill>
+            <a:srgbClr val="DDEBF7"/>
+          </a:solidFill>
+          <a:ln>
+            <a:solidFill>
+              <a:srgbClr val="B4B4B4"/>
+            </a:solidFill>
+          </a:ln>
+        </p:spPr>
+        <p:style>
+          <a:lnRef idx="1">
+            <a:schemeClr val="accent1"/>
+          </a:lnRef>
+          <a:fillRef idx="3">
+            <a:schemeClr val="accent1"/>
+          </a:fillRef>
+          <a:effectRef idx="2">
+            <a:schemeClr val="accent1"/>
+          </a:effectRef>
+          <a:fontRef idx="minor">
+            <a:schemeClr val="lt1"/>
+          </a:fontRef>
+        </p:style>
+        <p:txBody>
+          <a:bodyPr rtlCol="0" anchor="ctr"/>
+          <a:lstStyle/>
+          <a:p>
+            <a:pPr algn="ctr"/>
+          </a:p>
+        </p:txBody>
+      </p:sp>
+      <p:sp>
+        <p:nvSpPr>
+          <p:cNvPr id="7" name="TextBox 6"/>
+          <p:cNvSpPr txBox="1"/>
+          <p:nvPr/>
+        </p:nvSpPr>
+        <p:spPr>
+          <a:xfrm>
+            <a:off x="5312664" y="1527048"/>
+            <a:ext cx="5742431" cy="914400"/>
+          </a:xfrm>
+          <a:prstGeom prst="rect">
+            <a:avLst/>
+          </a:prstGeom>
+          <a:noFill/>
+        </p:spPr>
+        <p:txBody>
+          <a:bodyPr wrap="none">
+            <a:spAutoFit/>
+          </a:bodyPr>
+          <a:lstStyle/>
+          <a:p>
+            <a:r>
+              <a:rPr sz="1700" b="1">
+                <a:solidFill>
+                  <a:srgbClr val="16365C"/>
+                </a:solidFill>
+                <a:latin typeface="Tahoma"/>
+              </a:rPr>
+              <a:t>ขั้นตอน Demo</a:t>
+            </a:r>
+          </a:p>
+          <a:p>
+            <a:pPr>
+              <a:spcBef>
+                <a:spcPts val="500"/>
+              </a:spcBef>
+              <a:defRPr sz="1500">
+                <a:solidFill>
+                  <a:srgbClr val="282828"/>
+                </a:solidFill>
+                <a:latin typeface="Tahoma"/>
+              </a:defRPr>
+            </a:pPr>
+            <a:r>
+              <a:t>เปิด Docker API → ส่งรูปภาพ → ตรวจ JSON response</a:t>
+            </a:r>
+          </a:p>
+        </p:txBody>
+      </p:sp>
+      <p:sp>
+        <p:nvSpPr>
+          <p:cNvPr id="8" name="Rounded Rectangle 7"/>
+          <p:cNvSpPr/>
+          <p:nvPr/>
+        </p:nvSpPr>
+        <p:spPr>
+          <a:xfrm>
+            <a:off x="5166360" y="2880360"/>
+            <a:ext cx="6035040" cy="1097280"/>
+          </a:xfrm>
+          <a:prstGeom prst="roundRect">
+            <a:avLst/>
+          </a:prstGeom>
+          <a:solidFill>
+            <a:srgbClr val="70AD47"/>
+          </a:solidFill>
+          <a:ln>
+            <a:solidFill>
+              <a:srgbClr val="B4B4B4"/>
+            </a:solidFill>
+          </a:ln>
+        </p:spPr>
+        <p:style>
+          <a:lnRef idx="1">
+            <a:schemeClr val="accent1"/>
+          </a:lnRef>
+          <a:fillRef idx="3">
+            <a:schemeClr val="accent1"/>
+          </a:fillRef>
+          <a:effectRef idx="2">
+            <a:schemeClr val="accent1"/>
+          </a:effectRef>
+          <a:fontRef idx="minor">
+            <a:schemeClr val="lt1"/>
+          </a:fontRef>
+        </p:style>
+        <p:txBody>
+          <a:bodyPr rtlCol="0" anchor="ctr"/>
+          <a:lstStyle/>
+          <a:p>
+            <a:pPr algn="ctr"/>
+          </a:p>
+        </p:txBody>
+      </p:sp>
+      <p:sp>
+        <p:nvSpPr>
+          <p:cNvPr id="9" name="TextBox 8"/>
+          <p:cNvSpPr txBox="1"/>
+          <p:nvPr/>
+        </p:nvSpPr>
+        <p:spPr>
+          <a:xfrm>
+            <a:off x="5312664" y="2990088"/>
+            <a:ext cx="5742431" cy="914400"/>
+          </a:xfrm>
+          <a:prstGeom prst="rect">
+            <a:avLst/>
+          </a:prstGeom>
+          <a:noFill/>
+        </p:spPr>
+        <p:txBody>
+          <a:bodyPr wrap="none">
+            <a:spAutoFit/>
+          </a:bodyPr>
+          <a:lstStyle/>
+          <a:p>
+            <a:r>
+              <a:rPr sz="1700" b="1">
+                <a:solidFill>
+                  <a:srgbClr val="16365C"/>
+                </a:solidFill>
+                <a:latin typeface="Tahoma"/>
+              </a:rPr>
+              <a:t>ผลลัพธ์ที่ได้</a:t>
+            </a:r>
+          </a:p>
+          <a:p>
+            <a:pPr>
+              <a:spcBef>
+                <a:spcPts val="500"/>
+              </a:spcBef>
+              <a:defRPr sz="1400">
+                <a:solidFill>
+                  <a:srgbClr val="282828"/>
+                </a:solidFill>
+                <a:latin typeface="Tahoma"/>
+              </a:defRPr>
+            </a:pPr>
+            <a:r>
+              <a:t>model: apple/mobilevit-small | runtime: onnx-quantized</a:t>
+            </a:r>
+          </a:p>
+        </p:txBody>
+      </p:sp>
+      <p:sp>
+        <p:nvSpPr>
+          <p:cNvPr id="10" name="Rounded Rectangle 9"/>
+          <p:cNvSpPr/>
+          <p:nvPr/>
+        </p:nvSpPr>
+        <p:spPr>
+          <a:xfrm>
+            <a:off x="5166360" y="4343400"/>
+            <a:ext cx="6035040" cy="1097280"/>
+          </a:xfrm>
+          <a:prstGeom prst="roundRect">
+            <a:avLst/>
+          </a:prstGeom>
+          <a:solidFill>
+            <a:srgbClr val="ED7D31"/>
+          </a:solidFill>
+          <a:ln>
+            <a:solidFill>
+              <a:srgbClr val="B4B4B4"/>
+            </a:solidFill>
+          </a:ln>
+        </p:spPr>
+        <p:style>
+          <a:lnRef idx="1">
+            <a:schemeClr val="accent1"/>
+          </a:lnRef>
+          <a:fillRef idx="3">
+            <a:schemeClr val="accent1"/>
+          </a:fillRef>
+          <a:effectRef idx="2">
+            <a:schemeClr val="accent1"/>
+          </a:effectRef>
+          <a:fontRef idx="minor">
+            <a:schemeClr val="lt1"/>
+          </a:fontRef>
+        </p:style>
+        <p:txBody>
+          <a:bodyPr rtlCol="0" anchor="ctr"/>
+          <a:lstStyle/>
+          <a:p>
+            <a:pPr algn="ctr"/>
+          </a:p>
+        </p:txBody>
+      </p:sp>
+      <p:sp>
+        <p:nvSpPr>
+          <p:cNvPr id="11" name="TextBox 10"/>
+          <p:cNvSpPr txBox="1"/>
+          <p:nvPr/>
+        </p:nvSpPr>
+        <p:spPr>
+          <a:xfrm>
+            <a:off x="5312664" y="4453128"/>
+            <a:ext cx="5742431" cy="914400"/>
+          </a:xfrm>
+          <a:prstGeom prst="rect">
+            <a:avLst/>
+          </a:prstGeom>
+          <a:noFill/>
+        </p:spPr>
+        <p:txBody>
+          <a:bodyPr wrap="none">
+            <a:spAutoFit/>
+          </a:bodyPr>
+          <a:lstStyle/>
+          <a:p>
+            <a:r>
+              <a:rPr sz="1700" b="1">
+                <a:solidFill>
+                  <a:srgbClr val="16365C"/>
+                </a:solidFill>
+                <a:latin typeface="Tahoma"/>
+              </a:rPr>
+              <a:t>Top Predictions</a:t>
+            </a:r>
+          </a:p>
+          <a:p>
+            <a:pPr>
+              <a:spcBef>
+                <a:spcPts val="500"/>
+              </a:spcBef>
+              <a:defRPr sz="1400">
+                <a:solidFill>
+                  <a:srgbClr val="282828"/>
+                </a:solidFill>
+                <a:latin typeface="Tahoma"/>
+              </a:defRPr>
+            </a:pPr>
+            <a:r>
+              <a:t>tabby cat, Egyptian cat, tiger cat</a:t>
+            </a:r>
+          </a:p>
+        </p:txBody>
+      </p:sp>
+      <p:sp>
+        <p:nvSpPr>
+          <p:cNvPr id="12" name="TextBox 11"/>
+          <p:cNvSpPr txBox="1"/>
+          <p:nvPr/>
+        </p:nvSpPr>
+        <p:spPr>
+          <a:xfrm>
+            <a:off x="9646920" y="6446520"/>
+            <a:ext cx="1920240" cy="228600"/>
+          </a:xfrm>
+          <a:prstGeom prst="rect">
+            <a:avLst/>
+          </a:prstGeom>
+          <a:noFill/>
+        </p:spPr>
+        <p:txBody>
+          <a:bodyPr wrap="none">
+            <a:spAutoFit/>
+          </a:bodyPr>
+          <a:lstStyle/>
+          <a:p>
+            <a:pPr algn="r"/>
+            <a:r>
+              <a:rPr sz="900" b="0">
+                <a:solidFill>
+                  <a:srgbClr val="595959"/>
+                </a:solidFill>
+                <a:latin typeface="Tahoma"/>
+              </a:rPr>
+              <a:t>MobileViT MLOps | 15</a:t>
+            </a:r>
+          </a:p>
+        </p:txBody>
+      </p:sp>
+    </p:spTree>
+  </p:cSld>
+  <p:clrMapOvr>
+    <a:masterClrMapping/>
+  </p:clrMapOvr>
+</p:sld>
+</file>
+
+<file path=ppt/slides/slide16.xml><?xml version="1.0" encoding="utf-8"?>
+<p:sld xmlns:a="http://schemas.openxmlformats.org/drawingml/2006/main" xmlns:p="http://schemas.openxmlformats.org/presentationml/2006/main" xmlns:r="http://schemas.openxmlformats.org/officeDocument/2006/relationships">
+  <p:cSld>
+    <p:spTree>
+      <p:nvGrpSpPr>
+        <p:cNvPr id="1" name=""/>
+        <p:cNvGrpSpPr/>
+        <p:nvPr/>
+      </p:nvGrpSpPr>
+      <p:grpSpPr/>
+      <p:sp>
+        <p:nvSpPr>
+          <p:cNvPr id="2" name="TextBox 1"/>
+          <p:cNvSpPr txBox="1"/>
+          <p:nvPr/>
+        </p:nvSpPr>
+        <p:spPr>
+          <a:xfrm>
+            <a:off x="594360" y="320040"/>
+            <a:ext cx="10972800" cy="640080"/>
+          </a:xfrm>
+          <a:prstGeom prst="rect">
+            <a:avLst/>
+          </a:prstGeom>
+          <a:noFill/>
+        </p:spPr>
+        <p:txBody>
+          <a:bodyPr wrap="none">
+            <a:spAutoFit/>
+          </a:bodyPr>
+          <a:lstStyle/>
+          <a:p>
+            <a:pPr algn="l"/>
+            <a:r>
+              <a:rPr sz="2800" b="1">
+                <a:solidFill>
+                  <a:srgbClr val="16365C"/>
+                </a:solidFill>
+                <a:latin typeface="Tahoma"/>
+              </a:rPr>
+              <a:t>Deliverables ที่จัดทำ</a:t>
+            </a:r>
+          </a:p>
+        </p:txBody>
+      </p:sp>
+      <p:sp>
+        <p:nvSpPr>
+          <p:cNvPr id="3" name="Rectangle 2"/>
+          <p:cNvSpPr/>
+          <p:nvPr/>
+        </p:nvSpPr>
+        <p:spPr>
+          <a:xfrm>
+            <a:off x="594360" y="1024128"/>
+            <a:ext cx="10972800" cy="36576"/>
+          </a:xfrm>
+          <a:prstGeom prst="rect">
+            <a:avLst/>
+          </a:prstGeom>
+          <a:solidFill>
+            <a:srgbClr val="3275B5"/>
+          </a:solidFill>
+          <a:ln>
+            <a:noFill/>
+          </a:ln>
+        </p:spPr>
+        <p:style>
+          <a:lnRef idx="1">
+            <a:schemeClr val="accent1"/>
+          </a:lnRef>
+          <a:fillRef idx="3">
+            <a:schemeClr val="accent1"/>
+          </a:fillRef>
+          <a:effectRef idx="2">
+            <a:schemeClr val="accent1"/>
+          </a:effectRef>
+          <a:fontRef idx="minor">
+            <a:schemeClr val="lt1"/>
+          </a:fontRef>
+        </p:style>
+        <p:txBody>
+          <a:bodyPr rtlCol="0" anchor="ctr"/>
+          <a:lstStyle/>
+          <a:p>
+            <a:pPr algn="ctr"/>
+          </a:p>
+        </p:txBody>
+      </p:sp>
+      <p:sp>
+        <p:nvSpPr>
+          <p:cNvPr id="4" name="TextBox 3"/>
+          <p:cNvSpPr txBox="1"/>
+          <p:nvPr/>
+        </p:nvSpPr>
+        <p:spPr>
+          <a:xfrm>
+            <a:off x="777240" y="1417320"/>
+            <a:ext cx="10789920" cy="4297680"/>
+          </a:xfrm>
+          <a:prstGeom prst="rect">
+            <a:avLst/>
+          </a:prstGeom>
+          <a:noFill/>
+        </p:spPr>
+        <p:txBody>
+          <a:bodyPr wrap="none">
+            <a:spAutoFit/>
+          </a:bodyPr>
+          <a:lstStyle/>
+          <a:p>
+            <a:pPr>
+              <a:spcAft>
+                <a:spcPts val="800"/>
+              </a:spcAft>
+              <a:defRPr sz="2000">
+                <a:solidFill>
+                  <a:srgbClr val="282828"/>
+                </a:solidFill>
+                <a:latin typeface="Tahoma"/>
+              </a:defRPr>
+            </a:pPr>
+            <a:r>
+              <a:t>Source Code Repository บน GitHub</a:t>
+            </a:r>
+          </a:p>
+          <a:p>
+            <a:pPr>
+              <a:spcAft>
+                <a:spcPts val="800"/>
+              </a:spcAft>
+              <a:defRPr sz="2000">
+                <a:solidFill>
+                  <a:srgbClr val="282828"/>
+                </a:solidFill>
+                <a:latin typeface="Tahoma"/>
+              </a:defRPr>
+            </a:pPr>
+            <a:r>
+              <a:t>README.md ภาษาไทย พร้อมวิธีใช้งานและ cURL</a:t>
+            </a:r>
+          </a:p>
+          <a:p>
+            <a:pPr>
+              <a:spcAft>
+                <a:spcPts val="800"/>
+              </a:spcAft>
+              <a:defRPr sz="2000">
+                <a:solidFill>
+                  <a:srgbClr val="282828"/>
+                </a:solidFill>
+                <a:latin typeface="Tahoma"/>
+              </a:defRPr>
+            </a:pPr>
+            <a:r>
+              <a:t>Dockerfile และโมเดล ONNX Quantized</a:t>
+            </a:r>
+          </a:p>
+          <a:p>
+            <a:pPr>
+              <a:spcAft>
+                <a:spcPts val="800"/>
+              </a:spcAft>
+              <a:defRPr sz="2000">
+                <a:solidFill>
+                  <a:srgbClr val="282828"/>
+                </a:solidFill>
+                <a:latin typeface="Tahoma"/>
+              </a:defRPr>
+            </a:pPr>
+            <a:r>
+              <a:t>GitHub Actions สำหรับ CI/CD</a:t>
+            </a:r>
+          </a:p>
+          <a:p>
+            <a:pPr>
+              <a:spcAft>
+                <a:spcPts val="800"/>
+              </a:spcAft>
+              <a:defRPr sz="2000">
+                <a:solidFill>
+                  <a:srgbClr val="282828"/>
+                </a:solidFill>
+                <a:latin typeface="Tahoma"/>
+              </a:defRPr>
+            </a:pPr>
+            <a:r>
+              <a:t>Postman Collection และ JMeter Test Plan</a:t>
+            </a:r>
+          </a:p>
+          <a:p>
+            <a:pPr>
+              <a:spcAft>
+                <a:spcPts val="800"/>
+              </a:spcAft>
+              <a:defRPr sz="2000">
+                <a:solidFill>
+                  <a:srgbClr val="282828"/>
+                </a:solidFill>
+                <a:latin typeface="Tahoma"/>
+              </a:defRPr>
+            </a:pPr>
+            <a:r>
+              <a:t>รายงาน PDF และสไลด์นำเสนอ</a:t>
+            </a:r>
+          </a:p>
+        </p:txBody>
+      </p:sp>
+      <p:sp>
+        <p:nvSpPr>
+          <p:cNvPr id="5" name="TextBox 4"/>
+          <p:cNvSpPr txBox="1"/>
+          <p:nvPr/>
+        </p:nvSpPr>
+        <p:spPr>
+          <a:xfrm>
+            <a:off x="9646920" y="6446520"/>
+            <a:ext cx="1920240" cy="228600"/>
+          </a:xfrm>
+          <a:prstGeom prst="rect">
+            <a:avLst/>
+          </a:prstGeom>
+          <a:noFill/>
+        </p:spPr>
+        <p:txBody>
+          <a:bodyPr wrap="none">
+            <a:spAutoFit/>
+          </a:bodyPr>
+          <a:lstStyle/>
+          <a:p>
+            <a:pPr algn="r"/>
+            <a:r>
+              <a:rPr sz="900" b="0">
+                <a:solidFill>
+                  <a:srgbClr val="595959"/>
+                </a:solidFill>
+                <a:latin typeface="Tahoma"/>
+              </a:rPr>
+              <a:t>MobileViT MLOps | 16</a:t>
+            </a:r>
+          </a:p>
+        </p:txBody>
+      </p:sp>
+    </p:spTree>
+  </p:cSld>
+  <p:clrMapOvr>
+    <a:masterClrMapping/>
+  </p:clrMapOvr>
+</p:sld>
+</file>
+
+<file path=ppt/slides/slide17.xml><?xml version="1.0" encoding="utf-8"?>
+<p:sld xmlns:a="http://schemas.openxmlformats.org/drawingml/2006/main" xmlns:p="http://schemas.openxmlformats.org/presentationml/2006/main" xmlns:r="http://schemas.openxmlformats.org/officeDocument/2006/relationships">
+  <p:cSld>
+    <p:spTree>
+      <p:nvGrpSpPr>
+        <p:cNvPr id="1" name=""/>
+        <p:cNvGrpSpPr/>
+        <p:nvPr/>
+      </p:nvGrpSpPr>
+      <p:grpSpPr/>
+      <p:sp>
+        <p:nvSpPr>
+          <p:cNvPr id="2" name="TextBox 1"/>
+          <p:cNvSpPr txBox="1"/>
+          <p:nvPr/>
+        </p:nvSpPr>
+        <p:spPr>
+          <a:xfrm>
+            <a:off x="594360" y="320040"/>
+            <a:ext cx="10972800" cy="640080"/>
+          </a:xfrm>
+          <a:prstGeom prst="rect">
+            <a:avLst/>
+          </a:prstGeom>
+          <a:noFill/>
+        </p:spPr>
+        <p:txBody>
+          <a:bodyPr wrap="none">
+            <a:spAutoFit/>
+          </a:bodyPr>
+          <a:lstStyle/>
+          <a:p>
+            <a:pPr algn="l"/>
+            <a:r>
+              <a:rPr sz="2800" b="1">
+                <a:solidFill>
+                  <a:srgbClr val="16365C"/>
+                </a:solidFill>
+                <a:latin typeface="Tahoma"/>
+              </a:rPr>
+              <a:t>สรุปผล</a:t>
+            </a:r>
+          </a:p>
+        </p:txBody>
+      </p:sp>
+      <p:sp>
+        <p:nvSpPr>
+          <p:cNvPr id="3" name="Rectangle 2"/>
+          <p:cNvSpPr/>
+          <p:nvPr/>
+        </p:nvSpPr>
+        <p:spPr>
+          <a:xfrm>
+            <a:off x="594360" y="1024128"/>
+            <a:ext cx="10972800" cy="36576"/>
+          </a:xfrm>
+          <a:prstGeom prst="rect">
+            <a:avLst/>
+          </a:prstGeom>
+          <a:solidFill>
+            <a:srgbClr val="3275B5"/>
+          </a:solidFill>
+          <a:ln>
+            <a:noFill/>
+          </a:ln>
+        </p:spPr>
+        <p:style>
+          <a:lnRef idx="1">
+            <a:schemeClr val="accent1"/>
+          </a:lnRef>
+          <a:fillRef idx="3">
+            <a:schemeClr val="accent1"/>
+          </a:fillRef>
+          <a:effectRef idx="2">
+            <a:schemeClr val="accent1"/>
+          </a:effectRef>
+          <a:fontRef idx="minor">
+            <a:schemeClr val="lt1"/>
+          </a:fontRef>
+        </p:style>
+        <p:txBody>
+          <a:bodyPr rtlCol="0" anchor="ctr"/>
+          <a:lstStyle/>
+          <a:p>
+            <a:pPr algn="ctr"/>
+          </a:p>
+        </p:txBody>
+      </p:sp>
+      <p:sp>
+        <p:nvSpPr>
           <p:cNvPr id="4" name="TextBox 3"/>
           <p:cNvSpPr txBox="1"/>
           <p:nvPr/>
@@ -5528,7 +6569,7 @@
                 </a:solidFill>
                 <a:latin typeface="Tahoma"/>
               </a:rPr>
-              <a:t>MobileViT MLOps | 14</a:t>
+              <a:t>MobileViT MLOps | 17</a:t>
             </a:r>
           </a:p>
         </p:txBody>
@@ -9932,7 +10973,7 @@
                 </a:solidFill>
                 <a:latin typeface="Tahoma"/>
               </a:rPr>
-              <a:t>API และ Error Handling</a:t>
+              <a:t>ที่มาของข้อมูลและผลลัพธ์</a:t>
             </a:r>
           </a:p>
         </p:txBody>
@@ -9988,7 +11029,375 @@
         </p:nvSpPr>
         <p:spPr>
           <a:xfrm>
-            <a:off x="777240" y="1417320"/>
+            <a:off x="621792" y="1115568"/>
+            <a:ext cx="10789920" cy="320040"/>
+          </a:xfrm>
+          <a:prstGeom prst="rect">
+            <a:avLst/>
+          </a:prstGeom>
+          <a:noFill/>
+        </p:spPr>
+        <p:txBody>
+          <a:bodyPr wrap="none">
+            <a:spAutoFit/>
+          </a:bodyPr>
+          <a:lstStyle/>
+          <a:p>
+            <a:r>
+              <a:rPr sz="1300" b="0">
+                <a:solidFill>
+                  <a:srgbClr val="595959"/>
+                </a:solidFill>
+                <a:latin typeface="Tahoma"/>
+              </a:rPr>
+              <a:t>อธิบายว่าตัวเลขในสไลด์มาจากการทดสอบส่วนใด</a:t>
+            </a:r>
+          </a:p>
+        </p:txBody>
+      </p:sp>
+      <p:graphicFrame>
+        <p:nvGraphicFramePr>
+          <p:cNvPr id="5" name="Table 4"/>
+          <p:cNvGraphicFramePr>
+            <a:graphicFrameLocks noGrp="1"/>
+          </p:cNvGraphicFramePr>
+          <p:nvPr/>
+        </p:nvGraphicFramePr>
+        <p:xfrm>
+          <a:off x="731520" y="1463040"/>
+          <a:ext cx="10698480" cy="2468880"/>
+        </p:xfrm>
+        <a:graphic>
+          <a:graphicData uri="http://schemas.openxmlformats.org/drawingml/2006/table">
+            <a:tbl>
+              <a:tblPr firstRow="1" bandRow="1">
+                <a:tableStyleId>{5C22544A-7EE6-4342-B048-85BDC9FD1C3A}</a:tableStyleId>
+              </a:tblPr>
+              <a:tblGrid>
+                <a:gridCol w="3566160"/>
+                <a:gridCol w="3566160"/>
+                <a:gridCol w="3566160"/>
+              </a:tblGrid>
+              <a:tr h="493776">
+                <a:tc>
+                  <a:txBody>
+                    <a:bodyPr/>
+                    <a:lstStyle/>
+                    <a:p>
+                      <a:pPr algn="ctr"/>
+                      <a:r>
+                        <a:rPr sz="1000" b="1">
+                          <a:solidFill>
+                            <a:srgbClr val="FFFFFF"/>
+                          </a:solidFill>
+                          <a:latin typeface="Tahoma"/>
+                        </a:rPr>
+                        <a:t>ผลลัพธ์</a:t>
+                      </a:r>
+                    </a:p>
+                  </a:txBody>
+                  <a:tcPr>
+                    <a:solidFill>
+                      <a:srgbClr val="3275B5"/>
+                    </a:solidFill>
+                  </a:tcPr>
+                </a:tc>
+                <a:tc>
+                  <a:txBody>
+                    <a:bodyPr/>
+                    <a:lstStyle/>
+                    <a:p>
+                      <a:pPr algn="ctr"/>
+                      <a:r>
+                        <a:rPr sz="1000" b="1">
+                          <a:solidFill>
+                            <a:srgbClr val="FFFFFF"/>
+                          </a:solidFill>
+                          <a:latin typeface="Tahoma"/>
+                        </a:rPr>
+                        <a:t>ที่มา</a:t>
+                      </a:r>
+                    </a:p>
+                  </a:txBody>
+                  <a:tcPr>
+                    <a:solidFill>
+                      <a:srgbClr val="3275B5"/>
+                    </a:solidFill>
+                  </a:tcPr>
+                </a:tc>
+                <a:tc>
+                  <a:txBody>
+                    <a:bodyPr/>
+                    <a:lstStyle/>
+                    <a:p>
+                      <a:pPr algn="ctr"/>
+                      <a:r>
+                        <a:rPr sz="1000" b="1">
+                          <a:solidFill>
+                            <a:srgbClr val="FFFFFF"/>
+                          </a:solidFill>
+                          <a:latin typeface="Tahoma"/>
+                        </a:rPr>
+                        <a:t>นำไปใช้ในสไลด์</a:t>
+                      </a:r>
+                    </a:p>
+                  </a:txBody>
+                  <a:tcPr>
+                    <a:solidFill>
+                      <a:srgbClr val="3275B5"/>
+                    </a:solidFill>
+                  </a:tcPr>
+                </a:tc>
+              </a:tr>
+              <a:tr h="493776">
+                <a:tc>
+                  <a:txBody>
+                    <a:bodyPr/>
+                    <a:lstStyle/>
+                    <a:p>
+                      <a:pPr algn="ctr"/>
+                      <a:r>
+                        <a:rPr sz="1000" b="0">
+                          <a:solidFill>
+                            <a:srgbClr val="282828"/>
+                          </a:solidFill>
+                          <a:latin typeface="Tahoma"/>
+                        </a:rPr>
+                        <a:t>Model Size</a:t>
+                      </a:r>
+                    </a:p>
+                  </a:txBody>
+                  <a:tcPr/>
+                </a:tc>
+                <a:tc>
+                  <a:txBody>
+                    <a:bodyPr/>
+                    <a:lstStyle/>
+                    <a:p>
+                      <a:pPr algn="ctr"/>
+                      <a:r>
+                        <a:rPr sz="1000" b="0">
+                          <a:solidFill>
+                            <a:srgbClr val="282828"/>
+                          </a:solidFill>
+                          <a:latin typeface="Tahoma"/>
+                        </a:rPr>
+                        <a:t>ขนาดไฟล์โมเดลในโฟลเดอร์ models</a:t>
+                      </a:r>
+                    </a:p>
+                  </a:txBody>
+                  <a:tcPr/>
+                </a:tc>
+                <a:tc>
+                  <a:txBody>
+                    <a:bodyPr/>
+                    <a:lstStyle/>
+                    <a:p>
+                      <a:pPr algn="ctr"/>
+                      <a:r>
+                        <a:rPr sz="1000" b="0">
+                          <a:solidFill>
+                            <a:srgbClr val="282828"/>
+                          </a:solidFill>
+                          <a:latin typeface="Tahoma"/>
+                        </a:rPr>
+                        <a:t>เปรียบเทียบ PyTorch / ONNX / Quantized</a:t>
+                      </a:r>
+                    </a:p>
+                  </a:txBody>
+                  <a:tcPr/>
+                </a:tc>
+              </a:tr>
+              <a:tr h="493776">
+                <a:tc>
+                  <a:txBody>
+                    <a:bodyPr/>
+                    <a:lstStyle/>
+                    <a:p>
+                      <a:pPr algn="ctr"/>
+                      <a:r>
+                        <a:rPr sz="1000" b="0">
+                          <a:solidFill>
+                            <a:srgbClr val="282828"/>
+                          </a:solidFill>
+                          <a:latin typeface="Tahoma"/>
+                        </a:rPr>
+                        <a:t>Latency</a:t>
+                      </a:r>
+                    </a:p>
+                  </a:txBody>
+                  <a:tcPr/>
+                </a:tc>
+                <a:tc>
+                  <a:txBody>
+                    <a:bodyPr/>
+                    <a:lstStyle/>
+                    <a:p>
+                      <a:pPr algn="ctr"/>
+                      <a:r>
+                        <a:rPr sz="1000" b="0">
+                          <a:solidFill>
+                            <a:srgbClr val="282828"/>
+                          </a:solidFill>
+                          <a:latin typeface="Tahoma"/>
+                        </a:rPr>
+                        <a:t>จับเวลาการ inference ด้วยรูปภาพ benchmark.png</a:t>
+                      </a:r>
+                    </a:p>
+                  </a:txBody>
+                  <a:tcPr/>
+                </a:tc>
+                <a:tc>
+                  <a:txBody>
+                    <a:bodyPr/>
+                    <a:lstStyle/>
+                    <a:p>
+                      <a:pPr algn="ctr"/>
+                      <a:r>
+                        <a:rPr sz="1000" b="0">
+                          <a:solidFill>
+                            <a:srgbClr val="282828"/>
+                          </a:solidFill>
+                          <a:latin typeface="Tahoma"/>
+                        </a:rPr>
+                        <a:t>ประเมินความเร็วของแต่ละ runtime</a:t>
+                      </a:r>
+                    </a:p>
+                  </a:txBody>
+                  <a:tcPr/>
+                </a:tc>
+              </a:tr>
+              <a:tr h="493776">
+                <a:tc>
+                  <a:txBody>
+                    <a:bodyPr/>
+                    <a:lstStyle/>
+                    <a:p>
+                      <a:pPr algn="ctr"/>
+                      <a:r>
+                        <a:rPr sz="1000" b="0">
+                          <a:solidFill>
+                            <a:srgbClr val="282828"/>
+                          </a:solidFill>
+                          <a:latin typeface="Tahoma"/>
+                        </a:rPr>
+                        <a:t>Prediction</a:t>
+                      </a:r>
+                    </a:p>
+                  </a:txBody>
+                  <a:tcPr/>
+                </a:tc>
+                <a:tc>
+                  <a:txBody>
+                    <a:bodyPr/>
+                    <a:lstStyle/>
+                    <a:p>
+                      <a:pPr algn="ctr"/>
+                      <a:r>
+                        <a:rPr sz="1000" b="0">
+                          <a:solidFill>
+                            <a:srgbClr val="282828"/>
+                          </a:solidFill>
+                          <a:latin typeface="Tahoma"/>
+                        </a:rPr>
+                        <a:t>เรียก endpoint /predict ด้วยรูปภาพจริง</a:t>
+                      </a:r>
+                    </a:p>
+                  </a:txBody>
+                  <a:tcPr/>
+                </a:tc>
+                <a:tc>
+                  <a:txBody>
+                    <a:bodyPr/>
+                    <a:lstStyle/>
+                    <a:p>
+                      <a:pPr algn="ctr"/>
+                      <a:r>
+                        <a:rPr sz="1000" b="0">
+                          <a:solidFill>
+                            <a:srgbClr val="282828"/>
+                          </a:solidFill>
+                          <a:latin typeface="Tahoma"/>
+                        </a:rPr>
+                        <a:t>ยืนยันว่า API ใช้งานได้จริง</a:t>
+                      </a:r>
+                    </a:p>
+                  </a:txBody>
+                  <a:tcPr/>
+                </a:tc>
+              </a:tr>
+              <a:tr h="493776">
+                <a:tc>
+                  <a:txBody>
+                    <a:bodyPr/>
+                    <a:lstStyle/>
+                    <a:p>
+                      <a:pPr algn="ctr"/>
+                      <a:r>
+                        <a:rPr sz="1000" b="0">
+                          <a:solidFill>
+                            <a:srgbClr val="282828"/>
+                          </a:solidFill>
+                          <a:latin typeface="Tahoma"/>
+                        </a:rPr>
+                        <a:t>Load Test</a:t>
+                      </a:r>
+                    </a:p>
+                  </a:txBody>
+                  <a:tcPr/>
+                </a:tc>
+                <a:tc>
+                  <a:txBody>
+                    <a:bodyPr/>
+                    <a:lstStyle/>
+                    <a:p>
+                      <a:pPr algn="ctr"/>
+                      <a:r>
+                        <a:rPr sz="1000" b="0">
+                          <a:solidFill>
+                            <a:srgbClr val="282828"/>
+                          </a:solidFill>
+                          <a:latin typeface="Tahoma"/>
+                        </a:rPr>
+                        <a:t>ส่ง request พร้อมกันหลายรายการ</a:t>
+                      </a:r>
+                    </a:p>
+                  </a:txBody>
+                  <a:tcPr/>
+                </a:tc>
+                <a:tc>
+                  <a:txBody>
+                    <a:bodyPr/>
+                    <a:lstStyle/>
+                    <a:p>
+                      <a:pPr algn="ctr"/>
+                      <a:r>
+                        <a:rPr sz="1000" b="0">
+                          <a:solidFill>
+                            <a:srgbClr val="282828"/>
+                          </a:solidFill>
+                          <a:latin typeface="Tahoma"/>
+                        </a:rPr>
+                        <a:t>วิเคราะห์ throughput และ P95 latency</a:t>
+                      </a:r>
+                    </a:p>
+                  </a:txBody>
+                  <a:tcPr/>
+                </a:tc>
+              </a:tr>
+            </a:tbl>
+          </a:graphicData>
+        </a:graphic>
+      </p:graphicFrame>
+      <p:sp>
+        <p:nvSpPr>
+          <p:cNvPr id="6" name="TextBox 5"/>
+          <p:cNvSpPr txBox="1"/>
+          <p:nvPr/>
+        </p:nvSpPr>
+        <p:spPr>
+          <a:xfrm>
+            <a:off x="777240" y="4343400"/>
             <a:ext cx="10789920" cy="4297680"/>
           </a:xfrm>
           <a:prstGeom prst="rect">
@@ -10006,7 +11415,7 @@
               <a:spcAft>
                 <a:spcPts val="800"/>
               </a:spcAft>
-              <a:defRPr sz="1900">
+              <a:defRPr sz="1600">
                 <a:solidFill>
                   <a:srgbClr val="282828"/>
                 </a:solidFill>
@@ -10014,7 +11423,7 @@
               </a:defRPr>
             </a:pPr>
             <a:r>
-              <a:t>Endpoint หลัก: /predict รับไฟล์รูปภาพแบบ multipart/form-data</a:t>
+              <a:t>รูปภาพทดสอบเป็นภาพแมวจาก Hugging Face documentation-images</a:t>
             </a:r>
           </a:p>
           <a:p>
@@ -10022,7 +11431,7 @@
               <a:spcAft>
                 <a:spcPts val="800"/>
               </a:spcAft>
-              <a:defRPr sz="1900">
+              <a:defRPr sz="1600">
                 <a:solidFill>
                   <a:srgbClr val="282828"/>
                 </a:solidFill>
@@ -10030,7 +11439,7 @@
               </a:defRPr>
             </a:pPr>
             <a:r>
-              <a:t>รองรับไฟล์ JPEG, PNG และ WebP</a:t>
+              <a:t>ผลลัพธ์ benchmark ถูกบันทึกไว้ใน models/benchmark_results.json</a:t>
             </a:r>
           </a:p>
           <a:p>
@@ -10038,7 +11447,7 @@
               <a:spcAft>
                 <a:spcPts val="800"/>
               </a:spcAft>
-              <a:defRPr sz="1900">
+              <a:defRPr sz="1600">
                 <a:solidFill>
                   <a:srgbClr val="282828"/>
                 </a:solidFill>
@@ -10046,46 +11455,14 @@
               </a:defRPr>
             </a:pPr>
             <a:r>
-              <a:t>ตรวจสอบไฟล์ว่าง ไฟล์เสีย และขนาดไฟล์ก่อนเข้าโมเดล</a:t>
-            </a:r>
-          </a:p>
-          <a:p>
-            <a:pPr>
-              <a:spcAft>
-                <a:spcPts val="800"/>
-              </a:spcAft>
-              <a:defRPr sz="1900">
-                <a:solidFill>
-                  <a:srgbClr val="282828"/>
-                </a:solidFill>
-                <a:latin typeface="Tahoma"/>
-              </a:defRPr>
-            </a:pPr>
-            <a:r>
-              <a:t>ตอบกลับ 400 Bad Request เมื่อ input ไม่ถูกต้อง</a:t>
-            </a:r>
-          </a:p>
-          <a:p>
-            <a:pPr>
-              <a:spcAft>
-                <a:spcPts val="800"/>
-              </a:spcAft>
-              <a:defRPr sz="1900">
-                <a:solidFill>
-                  <a:srgbClr val="282828"/>
-                </a:solidFill>
-                <a:latin typeface="Tahoma"/>
-              </a:defRPr>
-            </a:pPr>
-            <a:r>
-              <a:t>ตอบกลับ 413 Request Entity Too Large เมื่อไฟล์ใหญ่เกินกำหนด</a:t>
-            </a:r>
-          </a:p>
-        </p:txBody>
-      </p:sp>
-      <p:sp>
-        <p:nvSpPr>
-          <p:cNvPr id="5" name="TextBox 4"/>
+              <a:t>ผล API ยืนยันจาก JSON response ที่มี model: apple/mobilevit-small และ runtime: onnx-quantized</a:t>
+            </a:r>
+          </a:p>
+        </p:txBody>
+      </p:sp>
+      <p:sp>
+        <p:nvSpPr>
+          <p:cNvPr id="7" name="TextBox 6"/>
           <p:cNvSpPr txBox="1"/>
           <p:nvPr/>
         </p:nvSpPr>
@@ -10166,7 +11543,7 @@
                 </a:solidFill>
                 <a:latin typeface="Tahoma"/>
               </a:rPr>
-              <a:t>ผลการทดสอบ API</a:t>
+              <a:t>วิธีวัดประสิทธิภาพของโมเดล</a:t>
             </a:r>
           </a:p>
         </p:txBody>
@@ -10222,14 +11599,14 @@
         </p:nvSpPr>
         <p:spPr>
           <a:xfrm>
-            <a:off x="822960" y="1417320"/>
-            <a:ext cx="3200400" cy="1188720"/>
+            <a:off x="731520" y="1417320"/>
+            <a:ext cx="3474720" cy="1234440"/>
           </a:xfrm>
           <a:prstGeom prst="roundRect">
             <a:avLst/>
           </a:prstGeom>
           <a:solidFill>
-            <a:srgbClr val="70AD47"/>
+            <a:srgbClr val="E8F2FA"/>
           </a:solidFill>
           <a:ln>
             <a:solidFill>
@@ -10267,8 +11644,8 @@
         </p:nvSpPr>
         <p:spPr>
           <a:xfrm>
-            <a:off x="969264" y="1527048"/>
-            <a:ext cx="2907792" cy="1005840"/>
+            <a:off x="877824" y="1527048"/>
+            <a:ext cx="3182112" cy="1051560"/>
           </a:xfrm>
           <a:prstGeom prst="rect">
             <a:avLst/>
@@ -10288,7 +11665,7 @@
                 </a:solidFill>
                 <a:latin typeface="Tahoma"/>
               </a:rPr>
-              <a:t>Unit Test</a:t>
+              <a:t>1. Baseline</a:t>
             </a:r>
           </a:p>
           <a:p>
@@ -10304,7 +11681,7 @@
               </a:defRPr>
             </a:pPr>
             <a:r>
-              <a:t>ผ่าน 3/3 tests</a:t>
+              <a:t>โหลดโมเดล PyTorch ต้นฉบับและวัดขนาด/เวลา inference</a:t>
             </a:r>
           </a:p>
         </p:txBody>
@@ -10317,14 +11694,14 @@
         </p:nvSpPr>
         <p:spPr>
           <a:xfrm>
-            <a:off x="4480560" y="1417320"/>
-            <a:ext cx="3200400" cy="1188720"/>
+            <a:off x="4389120" y="1417320"/>
+            <a:ext cx="3474720" cy="1234440"/>
           </a:xfrm>
           <a:prstGeom prst="roundRect">
             <a:avLst/>
           </a:prstGeom>
           <a:solidFill>
-            <a:srgbClr val="70AD47"/>
+            <a:srgbClr val="E8F2FA"/>
           </a:solidFill>
           <a:ln>
             <a:solidFill>
@@ -10362,8 +11739,8 @@
         </p:nvSpPr>
         <p:spPr>
           <a:xfrm>
-            <a:off x="4626864" y="1527048"/>
-            <a:ext cx="2907792" cy="1005840"/>
+            <a:off x="4535424" y="1527048"/>
+            <a:ext cx="3182112" cy="1051560"/>
           </a:xfrm>
           <a:prstGeom prst="rect">
             <a:avLst/>
@@ -10383,7 +11760,7 @@
                 </a:solidFill>
                 <a:latin typeface="Tahoma"/>
               </a:rPr>
-              <a:t>Docker Test</a:t>
+              <a:t>2. ONNX</a:t>
             </a:r>
           </a:p>
           <a:p>
@@ -10399,7 +11776,7 @@
               </a:defRPr>
             </a:pPr>
             <a:r>
-              <a:t>API รันและทำนายผลได้จริง</a:t>
+              <a:t>แปลงโมเดลเป็น ONNX แล้ววัด latency ด้วย ONNX Runtime</a:t>
             </a:r>
           </a:p>
         </p:txBody>
@@ -10412,14 +11789,14 @@
         </p:nvSpPr>
         <p:spPr>
           <a:xfrm>
-            <a:off x="8138160" y="1417320"/>
-            <a:ext cx="3200400" cy="1188720"/>
+            <a:off x="8046720" y="1417320"/>
+            <a:ext cx="3474720" cy="1234440"/>
           </a:xfrm>
           <a:prstGeom prst="roundRect">
             <a:avLst/>
           </a:prstGeom>
           <a:solidFill>
-            <a:srgbClr val="70AD47"/>
+            <a:srgbClr val="E8F2FA"/>
           </a:solidFill>
           <a:ln>
             <a:solidFill>
@@ -10457,8 +11834,8 @@
         </p:nvSpPr>
         <p:spPr>
           <a:xfrm>
-            <a:off x="8284464" y="1527048"/>
-            <a:ext cx="2907792" cy="1005840"/>
+            <a:off x="8193024" y="1527048"/>
+            <a:ext cx="3182112" cy="1051560"/>
           </a:xfrm>
           <a:prstGeom prst="rect">
             <a:avLst/>
@@ -10478,7 +11855,7 @@
                 </a:solidFill>
                 <a:latin typeface="Tahoma"/>
               </a:rPr>
-              <a:t>Prediction</a:t>
+              <a:t>3. Quantized</a:t>
             </a:r>
           </a:p>
           <a:p>
@@ -10494,7 +11871,7 @@
               </a:defRPr>
             </a:pPr>
             <a:r>
-              <a:t>runtime: onnx-quantized</a:t>
+              <a:t>ทำ Dynamic Quantization และวัดผลซ้ำด้วย input เดียวกัน</a:t>
             </a:r>
           </a:p>
         </p:txBody>
@@ -10508,8 +11885,8 @@
           <p:nvPr/>
         </p:nvGraphicFramePr>
         <p:xfrm>
-          <a:off x="1097280" y="3291840"/>
-          <a:ext cx="9875520" cy="1143000"/>
+          <a:off x="914400" y="3429000"/>
+          <a:ext cx="10332720" cy="1508760"/>
         </p:xfrm>
         <a:graphic>
           <a:graphicData uri="http://schemas.openxmlformats.org/drawingml/2006/table">
@@ -10518,10 +11895,11 @@
                 <a:tableStyleId>{5C22544A-7EE6-4342-B048-85BDC9FD1C3A}</a:tableStyleId>
               </a:tblPr>
               <a:tblGrid>
-                <a:gridCol w="4937760"/>
-                <a:gridCol w="4937760"/>
+                <a:gridCol w="3444240"/>
+                <a:gridCol w="3444240"/>
+                <a:gridCol w="3444240"/>
               </a:tblGrid>
-              <a:tr h="381000">
+              <a:tr h="377190">
                 <a:tc>
                   <a:txBody>
                     <a:bodyPr/>
@@ -10529,13 +11907,13 @@
                     <a:p>
                       <a:pPr algn="ctr"/>
                       <a:r>
-                        <a:rPr sz="1200" b="1">
+                        <a:rPr sz="1000" b="1">
                           <a:solidFill>
                             <a:srgbClr val="FFFFFF"/>
                           </a:solidFill>
                           <a:latin typeface="Tahoma"/>
                         </a:rPr>
-                        <a:t>Input</a:t>
+                        <a:t>Metric</a:t>
                       </a:r>
                     </a:p>
                   </a:txBody>
@@ -10552,13 +11930,36 @@
                     <a:p>
                       <a:pPr algn="ctr"/>
                       <a:r>
-                        <a:rPr sz="1200" b="1">
+                        <a:rPr sz="1000" b="1">
                           <a:solidFill>
                             <a:srgbClr val="FFFFFF"/>
                           </a:solidFill>
                           <a:latin typeface="Tahoma"/>
                         </a:rPr>
-                        <a:t>ผลลัพธ์</a:t>
+                        <a:t>ความหมาย</a:t>
+                      </a:r>
+                    </a:p>
+                  </a:txBody>
+                  <a:tcPr>
+                    <a:solidFill>
+                      <a:srgbClr val="3275B5"/>
+                    </a:solidFill>
+                  </a:tcPr>
+                </a:tc>
+                <a:tc>
+                  <a:txBody>
+                    <a:bodyPr/>
+                    <a:lstStyle/>
+                    <a:p>
+                      <a:pPr algn="ctr"/>
+                      <a:r>
+                        <a:rPr sz="1000" b="1">
+                          <a:solidFill>
+                            <a:srgbClr val="FFFFFF"/>
+                          </a:solidFill>
+                          <a:latin typeface="Tahoma"/>
+                        </a:rPr>
+                        <a:t>เหตุผลที่ใช้วัด</a:t>
                       </a:r>
                     </a:p>
                   </a:txBody>
@@ -10569,7 +11970,7 @@
                   </a:tcPr>
                 </a:tc>
               </a:tr>
-              <a:tr h="381000">
+              <a:tr h="377190">
                 <a:tc>
                   <a:txBody>
                     <a:bodyPr/>
@@ -10577,13 +11978,13 @@
                     <a:p>
                       <a:pPr algn="ctr"/>
                       <a:r>
-                        <a:rPr sz="1200" b="0">
+                        <a:rPr sz="1000" b="0">
                           <a:solidFill>
                             <a:srgbClr val="282828"/>
                           </a:solidFill>
                           <a:latin typeface="Tahoma"/>
                         </a:rPr>
-                        <a:t>sample_images/benchmark.png</a:t>
+                        <a:t>Model Size</a:t>
                       </a:r>
                     </a:p>
                   </a:txBody>
@@ -10596,34 +11997,13 @@
                     <a:p>
                       <a:pPr algn="ctr"/>
                       <a:r>
-                        <a:rPr sz="1200" b="0">
+                        <a:rPr sz="1000" b="0">
                           <a:solidFill>
                             <a:srgbClr val="282828"/>
                           </a:solidFill>
                           <a:latin typeface="Tahoma"/>
                         </a:rPr>
-                        <a:t>tabby cat, Egyptian cat, tiger cat</a:t>
-                      </a:r>
-                    </a:p>
-                  </a:txBody>
-                  <a:tcPr/>
-                </a:tc>
-              </a:tr>
-              <a:tr h="381000">
-                <a:tc>
-                  <a:txBody>
-                    <a:bodyPr/>
-                    <a:lstStyle/>
-                    <a:p>
-                      <a:pPr algn="ctr"/>
-                      <a:r>
-                        <a:rPr sz="1200" b="0">
-                          <a:solidFill>
-                            <a:srgbClr val="282828"/>
-                          </a:solidFill>
-                          <a:latin typeface="Tahoma"/>
-                        </a:rPr>
-                        <a:t>ไฟล์ text/plain</a:t>
+                        <a:t>ขนาดไฟล์โมเดล</a:t>
                       </a:r>
                     </a:p>
                   </a:txBody>
@@ -10636,13 +12016,131 @@
                     <a:p>
                       <a:pPr algn="ctr"/>
                       <a:r>
-                        <a:rPr sz="1200" b="0">
+                        <a:rPr sz="1000" b="0">
                           <a:solidFill>
                             <a:srgbClr val="282828"/>
                           </a:solidFill>
                           <a:latin typeface="Tahoma"/>
                         </a:rPr>
-                        <a:t>400 Bad Request</a:t>
+                        <a:t>ดูว่า optimization ลดขนาดได้เท่าไร</a:t>
+                      </a:r>
+                    </a:p>
+                  </a:txBody>
+                  <a:tcPr/>
+                </a:tc>
+              </a:tr>
+              <a:tr h="377190">
+                <a:tc>
+                  <a:txBody>
+                    <a:bodyPr/>
+                    <a:lstStyle/>
+                    <a:p>
+                      <a:pPr algn="ctr"/>
+                      <a:r>
+                        <a:rPr sz="1000" b="0">
+                          <a:solidFill>
+                            <a:srgbClr val="282828"/>
+                          </a:solidFill>
+                          <a:latin typeface="Tahoma"/>
+                        </a:rPr>
+                        <a:t>Average Latency</a:t>
+                      </a:r>
+                    </a:p>
+                  </a:txBody>
+                  <a:tcPr/>
+                </a:tc>
+                <a:tc>
+                  <a:txBody>
+                    <a:bodyPr/>
+                    <a:lstStyle/>
+                    <a:p>
+                      <a:pPr algn="ctr"/>
+                      <a:r>
+                        <a:rPr sz="1000" b="0">
+                          <a:solidFill>
+                            <a:srgbClr val="282828"/>
+                          </a:solidFill>
+                          <a:latin typeface="Tahoma"/>
+                        </a:rPr>
+                        <a:t>เวลา inference เฉลี่ย</a:t>
+                      </a:r>
+                    </a:p>
+                  </a:txBody>
+                  <a:tcPr/>
+                </a:tc>
+                <a:tc>
+                  <a:txBody>
+                    <a:bodyPr/>
+                    <a:lstStyle/>
+                    <a:p>
+                      <a:pPr algn="ctr"/>
+                      <a:r>
+                        <a:rPr sz="1000" b="0">
+                          <a:solidFill>
+                            <a:srgbClr val="282828"/>
+                          </a:solidFill>
+                          <a:latin typeface="Tahoma"/>
+                        </a:rPr>
+                        <a:t>ดูความเร็วโดยรวม</a:t>
+                      </a:r>
+                    </a:p>
+                  </a:txBody>
+                  <a:tcPr/>
+                </a:tc>
+              </a:tr>
+              <a:tr h="377190">
+                <a:tc>
+                  <a:txBody>
+                    <a:bodyPr/>
+                    <a:lstStyle/>
+                    <a:p>
+                      <a:pPr algn="ctr"/>
+                      <a:r>
+                        <a:rPr sz="1000" b="0">
+                          <a:solidFill>
+                            <a:srgbClr val="282828"/>
+                          </a:solidFill>
+                          <a:latin typeface="Tahoma"/>
+                        </a:rPr>
+                        <a:t>P95 Latency</a:t>
+                      </a:r>
+                    </a:p>
+                  </a:txBody>
+                  <a:tcPr/>
+                </a:tc>
+                <a:tc>
+                  <a:txBody>
+                    <a:bodyPr/>
+                    <a:lstStyle/>
+                    <a:p>
+                      <a:pPr algn="ctr"/>
+                      <a:r>
+                        <a:rPr sz="1000" b="0">
+                          <a:solidFill>
+                            <a:srgbClr val="282828"/>
+                          </a:solidFill>
+                          <a:latin typeface="Tahoma"/>
+                        </a:rPr>
+                        <a:t>เวลาที่ 95% ของ request ไม่เกินค่านี้</a:t>
+                      </a:r>
+                    </a:p>
+                  </a:txBody>
+                  <a:tcPr/>
+                </a:tc>
+                <a:tc>
+                  <a:txBody>
+                    <a:bodyPr/>
+                    <a:lstStyle/>
+                    <a:p>
+                      <a:pPr algn="ctr"/>
+                      <a:r>
+                        <a:rPr sz="1000" b="0">
+                          <a:solidFill>
+                            <a:srgbClr val="282828"/>
+                          </a:solidFill>
+                          <a:latin typeface="Tahoma"/>
+                        </a:rPr>
+                        <a:t>ดูความเสถียรของ response time</a:t>
                       </a:r>
                     </a:p>
                   </a:txBody>

</xml_diff>